<commit_message>
feat(reminder-series): implement reminder series with frequency and sync support
- Add reminder series frequency field to support recurring reminders (daily, weekly, monthly, etc.)
- Add series end date and series ID fields to track recurring reminder groups
- Implement SeriesGenerator for creating individual reminder instances from series templates
- Add series propagation dialogs for Android and web to handle edits (this event, this and future, all events)
- Update sync push/pull services to handle series data across calendar events and reminders
- Add database migrations for new reminder series fields
- Implement series-aware repository commands for calendar events and reminders
- Add comprehensive test coverage for series generation and sync behavior
- Update UI forms to support frequency selection and series action dialogs
- Update backup serialization/deserialization to preserve series metadata
- Enhance database schemas and entity configurations for series relationships
</commit_message>
<xml_diff>
--- a/Planixor_Marketing.pptx
+++ b/Planixor_Marketing.pptx
@@ -321,7 +321,7 @@
           <a:p>
             <a:fld id="{5BCAD085-E8A6-8845-BD4E-CB4CCA059FC4}" type="datetimeFigureOut">
               <a:rPr lang="en-US" smtClean="0"/>
-              <a:t>7/4/2026</a:t>
+              <a:t>7/7/2026</a:t>
             </a:fld>
             <a:endParaRPr lang="en-US"/>
           </a:p>
@@ -489,7 +489,7 @@
           <a:p>
             <a:fld id="{5BCAD085-E8A6-8845-BD4E-CB4CCA059FC4}" type="datetimeFigureOut">
               <a:rPr lang="en-US" smtClean="0"/>
-              <a:t>7/4/2026</a:t>
+              <a:t>7/7/2026</a:t>
             </a:fld>
             <a:endParaRPr lang="en-US"/>
           </a:p>
@@ -667,7 +667,7 @@
           <a:p>
             <a:fld id="{5BCAD085-E8A6-8845-BD4E-CB4CCA059FC4}" type="datetimeFigureOut">
               <a:rPr lang="en-US" smtClean="0"/>
-              <a:t>7/4/2026</a:t>
+              <a:t>7/7/2026</a:t>
             </a:fld>
             <a:endParaRPr lang="en-US"/>
           </a:p>
@@ -835,7 +835,7 @@
           <a:p>
             <a:fld id="{5BCAD085-E8A6-8845-BD4E-CB4CCA059FC4}" type="datetimeFigureOut">
               <a:rPr lang="en-US" smtClean="0"/>
-              <a:t>7/4/2026</a:t>
+              <a:t>7/7/2026</a:t>
             </a:fld>
             <a:endParaRPr lang="en-US"/>
           </a:p>
@@ -1080,7 +1080,7 @@
           <a:p>
             <a:fld id="{5BCAD085-E8A6-8845-BD4E-CB4CCA059FC4}" type="datetimeFigureOut">
               <a:rPr lang="en-US" smtClean="0"/>
-              <a:t>7/4/2026</a:t>
+              <a:t>7/7/2026</a:t>
             </a:fld>
             <a:endParaRPr lang="en-US"/>
           </a:p>
@@ -1365,7 +1365,7 @@
           <a:p>
             <a:fld id="{5BCAD085-E8A6-8845-BD4E-CB4CCA059FC4}" type="datetimeFigureOut">
               <a:rPr lang="en-US" smtClean="0"/>
-              <a:t>7/4/2026</a:t>
+              <a:t>7/7/2026</a:t>
             </a:fld>
             <a:endParaRPr lang="en-US"/>
           </a:p>
@@ -1784,7 +1784,7 @@
           <a:p>
             <a:fld id="{5BCAD085-E8A6-8845-BD4E-CB4CCA059FC4}" type="datetimeFigureOut">
               <a:rPr lang="en-US" smtClean="0"/>
-              <a:t>7/4/2026</a:t>
+              <a:t>7/7/2026</a:t>
             </a:fld>
             <a:endParaRPr lang="en-US"/>
           </a:p>
@@ -1901,7 +1901,7 @@
           <a:p>
             <a:fld id="{5BCAD085-E8A6-8845-BD4E-CB4CCA059FC4}" type="datetimeFigureOut">
               <a:rPr lang="en-US" smtClean="0"/>
-              <a:t>7/4/2026</a:t>
+              <a:t>7/7/2026</a:t>
             </a:fld>
             <a:endParaRPr lang="en-US"/>
           </a:p>
@@ -1996,7 +1996,7 @@
           <a:p>
             <a:fld id="{5BCAD085-E8A6-8845-BD4E-CB4CCA059FC4}" type="datetimeFigureOut">
               <a:rPr lang="en-US" smtClean="0"/>
-              <a:t>7/4/2026</a:t>
+              <a:t>7/7/2026</a:t>
             </a:fld>
             <a:endParaRPr lang="en-US"/>
           </a:p>
@@ -2271,7 +2271,7 @@
           <a:p>
             <a:fld id="{5BCAD085-E8A6-8845-BD4E-CB4CCA059FC4}" type="datetimeFigureOut">
               <a:rPr lang="en-US" smtClean="0"/>
-              <a:t>7/4/2026</a:t>
+              <a:t>7/7/2026</a:t>
             </a:fld>
             <a:endParaRPr lang="en-US"/>
           </a:p>
@@ -2523,7 +2523,7 @@
           <a:p>
             <a:fld id="{5BCAD085-E8A6-8845-BD4E-CB4CCA059FC4}" type="datetimeFigureOut">
               <a:rPr lang="en-US" smtClean="0"/>
-              <a:t>7/4/2026</a:t>
+              <a:t>7/7/2026</a:t>
             </a:fld>
             <a:endParaRPr lang="en-US"/>
           </a:p>
@@ -2734,7 +2734,7 @@
           <a:p>
             <a:fld id="{5BCAD085-E8A6-8845-BD4E-CB4CCA059FC4}" type="datetimeFigureOut">
               <a:rPr lang="en-US" smtClean="0"/>
-              <a:t>7/4/2026</a:t>
+              <a:t>7/7/2026</a:t>
             </a:fld>
             <a:endParaRPr lang="en-US"/>
           </a:p>
@@ -3157,7 +3157,7 @@
           <a:lstStyle/>
           <a:p>
             <a:pPr algn="ctr"/>
-            <a:endParaRPr/>
+            <a:endParaRPr lang="es-ES" noProof="0" dirty="0"/>
           </a:p>
         </p:txBody>
       </p:sp>
@@ -3192,6 +3192,7 @@
               </a:defRPr>
             </a:pPr>
             <a:r>
+              <a:rPr lang="es-ES" noProof="0" dirty="0"/>
               <a:t>Planixor</a:t>
             </a:r>
           </a:p>
@@ -3206,7 +3207,7 @@
         <p:spPr>
           <a:xfrm>
             <a:off x="731520" y="3474720"/>
-            <a:ext cx="9144000" cy="731520"/>
+            <a:ext cx="9144000" cy="461665"/>
           </a:xfrm>
           <a:prstGeom prst="rect">
             <a:avLst/>
@@ -3228,7 +3229,8 @@
               </a:defRPr>
             </a:pPr>
             <a:r>
-              <a:t>Organiza tu tiempo. Potencia tu dia.</a:t>
+              <a:rPr lang="es-ES" noProof="0" dirty="0"/>
+              <a:t>Organiza tu tiempo. Potencia tu día.</a:t>
             </a:r>
           </a:p>
         </p:txBody>
@@ -3264,24 +3266,8 @@
               </a:defRPr>
             </a:pPr>
             <a:r>
-              <a:rPr dirty="0"/>
-              <a:t>Tu </a:t>
-            </a:r>
-            <a:r>
-              <a:rPr dirty="0" err="1"/>
-              <a:t>calendario</a:t>
-            </a:r>
-            <a:r>
-              <a:rPr dirty="0"/>
-              <a:t>. </a:t>
-            </a:r>
-            <a:r>
-              <a:rPr lang="es-ES" dirty="0"/>
-              <a:t>Tus eventos</a:t>
-            </a:r>
-            <a:r>
-              <a:rPr dirty="0"/>
-              <a:t>. Tu control.</a:t>
+              <a:rPr lang="es-ES" noProof="0" dirty="0"/>
+              <a:t>Tu calendario. Tus eventos. Tu control.</a:t>
             </a:r>
           </a:p>
         </p:txBody>
@@ -3317,8 +3303,18 @@
               </a:defRPr>
             </a:pPr>
             <a:r>
-              <a:t>by Codenized</a:t>
-            </a:r>
+              <a:rPr lang="es-ES" noProof="0" dirty="0" err="1"/>
+              <a:t>by</a:t>
+            </a:r>
+            <a:r>
+              <a:rPr lang="es-ES" noProof="0" dirty="0"/>
+              <a:t> </a:t>
+            </a:r>
+            <a:r>
+              <a:rPr lang="es-ES" noProof="0" dirty="0" err="1"/>
+              <a:t>Codenized</a:t>
+            </a:r>
+            <a:endParaRPr lang="es-ES" noProof="0" dirty="0"/>
           </a:p>
         </p:txBody>
       </p:sp>
@@ -3431,7 +3427,7 @@
           <a:lstStyle/>
           <a:p>
             <a:pPr algn="ctr"/>
-            <a:endParaRPr/>
+            <a:endParaRPr lang="es-ES" noProof="0" dirty="0"/>
           </a:p>
         </p:txBody>
       </p:sp>
@@ -3466,8 +3462,14 @@
               </a:defRPr>
             </a:pPr>
             <a:r>
-              <a:t>Offline-First: Privacidad por Diseno</a:t>
-            </a:r>
+              <a:rPr lang="es-ES" noProof="0" dirty="0"/>
+              <a:t>Offline-First: Privacidad por </a:t>
+            </a:r>
+            <a:r>
+              <a:rPr lang="es-ES" noProof="0" dirty="0" err="1"/>
+              <a:t>Diseno</a:t>
+            </a:r>
+            <a:endParaRPr lang="es-ES" noProof="0" dirty="0"/>
           </a:p>
         </p:txBody>
       </p:sp>
@@ -3502,6 +3504,7 @@
               </a:defRPr>
             </a:pPr>
             <a:r>
+              <a:rPr lang="es-ES" noProof="0" dirty="0"/>
               <a:t>Planixor funciona completamente sin internet. Tus datos nunca salen de tu dispositivo a menos que tu lo decidas.</a:t>
             </a:r>
           </a:p>
@@ -3538,6 +3541,7 @@
               </a:defRPr>
             </a:pPr>
             <a:r>
+              <a:rPr lang="es-ES" noProof="0" dirty="0"/>
               <a:t>Como funciona</a:t>
             </a:r>
           </a:p>
@@ -3552,7 +3556,7 @@
         <p:spPr>
           <a:xfrm>
             <a:off x="731520" y="3108960"/>
-            <a:ext cx="5029200" cy="3200400"/>
+            <a:ext cx="5029200" cy="1656864"/>
           </a:xfrm>
           <a:prstGeom prst="rect">
             <a:avLst/>
@@ -3577,7 +3581,16 @@
               </a:defRPr>
             </a:pPr>
             <a:r>
-              <a:t>Web: datos en IndexedDB (navegador)</a:t>
+              <a:rPr lang="es-ES" noProof="0" dirty="0"/>
+              <a:t>Web: datos en </a:t>
+            </a:r>
+            <a:r>
+              <a:rPr lang="es-ES" noProof="0" dirty="0" err="1"/>
+              <a:t>IndexedDB</a:t>
+            </a:r>
+            <a:r>
+              <a:rPr lang="es-ES" noProof="0" dirty="0"/>
+              <a:t> (navegador)</a:t>
             </a:r>
           </a:p>
           <a:p>
@@ -3593,6 +3606,7 @@
               </a:defRPr>
             </a:pPr>
             <a:r>
+              <a:rPr lang="es-ES" noProof="0" dirty="0"/>
               <a:t>Android: datos en SQLite (dispositivo)</a:t>
             </a:r>
           </a:p>
@@ -3609,6 +3623,7 @@
               </a:defRPr>
             </a:pPr>
             <a:r>
+              <a:rPr lang="es-ES" noProof="0" dirty="0"/>
               <a:t>Sin cuenta, sin registro, sin servidor</a:t>
             </a:r>
           </a:p>
@@ -3625,7 +3640,8 @@
               </a:defRPr>
             </a:pPr>
             <a:r>
-              <a:t>Funcionalidad completa sin conexion</a:t>
+              <a:rPr lang="es-ES" noProof="0" dirty="0"/>
+              <a:t>Funcionalidad completa sin conexión</a:t>
             </a:r>
           </a:p>
           <a:p>
@@ -3641,6 +3657,7 @@
               </a:defRPr>
             </a:pPr>
             <a:r>
+              <a:rPr lang="es-ES" noProof="0" dirty="0"/>
               <a:t>Tus datos = solo tuyos</a:t>
             </a:r>
           </a:p>
@@ -3677,6 +3694,7 @@
               </a:defRPr>
             </a:pPr>
             <a:r>
+              <a:rPr lang="es-ES" noProof="0" dirty="0"/>
               <a:t>Beneficios</a:t>
             </a:r>
           </a:p>
@@ -3691,7 +3709,7 @@
         <p:spPr>
           <a:xfrm>
             <a:off x="6400800" y="3108960"/>
-            <a:ext cx="5029200" cy="3200400"/>
+            <a:ext cx="5029200" cy="1656864"/>
           </a:xfrm>
           <a:prstGeom prst="rect">
             <a:avLst/>
@@ -3716,7 +3734,8 @@
               </a:defRPr>
             </a:pPr>
             <a:r>
-              <a:t>Velocidad instantanea (sin latencia de red)</a:t>
+              <a:rPr lang="es-ES" noProof="0" dirty="0"/>
+              <a:t>Velocidad instantánea (sin latencia de red)</a:t>
             </a:r>
           </a:p>
           <a:p>
@@ -3732,6 +3751,7 @@
               </a:defRPr>
             </a:pPr>
             <a:r>
+              <a:rPr lang="es-ES" noProof="0" dirty="0"/>
               <a:t>Privacidad absoluta por defecto</a:t>
             </a:r>
           </a:p>
@@ -3748,6 +3768,7 @@
               </a:defRPr>
             </a:pPr>
             <a:r>
+              <a:rPr lang="es-ES" noProof="0" dirty="0"/>
               <a:t>Funciona en aviones, metro, rural</a:t>
             </a:r>
           </a:p>
@@ -3764,7 +3785,8 @@
               </a:defRPr>
             </a:pPr>
             <a:r>
-              <a:t>Sin costos de suscripcion de nube</a:t>
+              <a:rPr lang="es-ES" noProof="0" dirty="0"/>
+              <a:t>Sin costos de suscripción de nube</a:t>
             </a:r>
           </a:p>
           <a:p>
@@ -3780,6 +3802,7 @@
               </a:defRPr>
             </a:pPr>
             <a:r>
+              <a:rPr lang="es-ES" noProof="0" dirty="0"/>
               <a:t>Cumplimiento GDPR simplificado</a:t>
             </a:r>
           </a:p>
@@ -3858,7 +3881,7 @@
           <a:lstStyle/>
           <a:p>
             <a:pPr algn="ctr"/>
-            <a:endParaRPr/>
+            <a:endParaRPr lang="es-ES" noProof="0" dirty="0"/>
           </a:p>
         </p:txBody>
       </p:sp>
@@ -3871,7 +3894,7 @@
         <p:spPr>
           <a:xfrm>
             <a:off x="731520" y="457200"/>
-            <a:ext cx="9144000" cy="731520"/>
+            <a:ext cx="9144000" cy="646331"/>
           </a:xfrm>
           <a:prstGeom prst="rect">
             <a:avLst/>
@@ -3893,7 +3916,8 @@
               </a:defRPr>
             </a:pPr>
             <a:r>
-              <a:t>Sincronizacion: Tu Servidor, Tus Reglas</a:t>
+              <a:rPr lang="es-ES" noProof="0" dirty="0"/>
+              <a:t>Sincronización: Tu Servidor, Tus Reglas</a:t>
             </a:r>
           </a:p>
         </p:txBody>
@@ -3907,7 +3931,7 @@
         <p:spPr>
           <a:xfrm>
             <a:off x="731520" y="1280160"/>
-            <a:ext cx="10058400" cy="914400"/>
+            <a:ext cx="10058400" cy="646331"/>
           </a:xfrm>
           <a:prstGeom prst="rect">
             <a:avLst/>
@@ -3929,7 +3953,32 @@
               </a:defRPr>
             </a:pPr>
             <a:r>
-              <a:t>Sincronizacion bidireccional opcional con tu propio backend auto-hospedado. Sin terceros, sin suscripciones cloud.</a:t>
+              <a:rPr lang="es-ES" noProof="0" dirty="0"/>
+              <a:t>Sincronización bidireccional opcional con tu propio </a:t>
+            </a:r>
+            <a:r>
+              <a:rPr lang="es-ES" noProof="0" dirty="0" err="1"/>
+              <a:t>backend</a:t>
+            </a:r>
+            <a:r>
+              <a:rPr lang="es-ES" noProof="0" dirty="0"/>
+              <a:t> </a:t>
+            </a:r>
+            <a:r>
+              <a:rPr lang="es-ES" noProof="0" dirty="0" err="1"/>
+              <a:t>auto-hospedado</a:t>
+            </a:r>
+            <a:r>
+              <a:rPr lang="es-ES" noProof="0" dirty="0"/>
+              <a:t>. Sin terceros, sin suscripciones </a:t>
+            </a:r>
+            <a:r>
+              <a:rPr lang="es-ES" noProof="0" dirty="0" err="1"/>
+              <a:t>cloud</a:t>
+            </a:r>
+            <a:r>
+              <a:rPr lang="es-ES" noProof="0" dirty="0"/>
+              <a:t>.</a:t>
             </a:r>
           </a:p>
         </p:txBody>
@@ -3943,7 +3992,7 @@
         <p:spPr>
           <a:xfrm>
             <a:off x="731520" y="2286000"/>
-            <a:ext cx="10058400" cy="4114800"/>
+            <a:ext cx="10058400" cy="3129062"/>
           </a:xfrm>
           <a:prstGeom prst="rect">
             <a:avLst/>
@@ -3968,7 +4017,24 @@
               </a:defRPr>
             </a:pPr>
             <a:r>
-              <a:t>Sincronizacion bidireccional: push + pull en cada ciclo</a:t>
+              <a:rPr lang="es-ES" noProof="0" dirty="0"/>
+              <a:t>Sincronización bidireccional: </a:t>
+            </a:r>
+            <a:r>
+              <a:rPr lang="es-ES" noProof="0" dirty="0" err="1"/>
+              <a:t>push</a:t>
+            </a:r>
+            <a:r>
+              <a:rPr lang="es-ES" noProof="0" dirty="0"/>
+              <a:t> + </a:t>
+            </a:r>
+            <a:r>
+              <a:rPr lang="es-ES" noProof="0" dirty="0" err="1"/>
+              <a:t>pull</a:t>
+            </a:r>
+            <a:r>
+              <a:rPr lang="es-ES" noProof="0" dirty="0"/>
+              <a:t> en cada ciclo</a:t>
             </a:r>
           </a:p>
           <a:p>
@@ -3984,6 +4050,7 @@
               </a:defRPr>
             </a:pPr>
             <a:r>
+              <a:rPr lang="es-ES" noProof="0" dirty="0"/>
               <a:t>Intervalo configurable: 5, 10, 15, 20, 25, 30, 45 o 60 minutos</a:t>
             </a:r>
           </a:p>
@@ -4000,7 +4067,12 @@
               </a:defRPr>
             </a:pPr>
             <a:r>
-              <a:t>Sync automatico al abrir la app y al cerrarla</a:t>
+              <a:rPr lang="es-ES" noProof="0" dirty="0" err="1"/>
+              <a:t>Sync</a:t>
+            </a:r>
+            <a:r>
+              <a:rPr lang="es-ES" noProof="0" dirty="0"/>
+              <a:t> automático al abrir la app y al cerrarla</a:t>
             </a:r>
           </a:p>
           <a:p>
@@ -4016,7 +4088,8 @@
               </a:defRPr>
             </a:pPr>
             <a:r>
-              <a:t>Deteccion inteligente de conectividad</a:t>
+              <a:rPr lang="es-ES" noProof="0" dirty="0"/>
+              <a:t>Detección inteligente de conectividad</a:t>
             </a:r>
           </a:p>
           <a:p>
@@ -4032,7 +4105,12 @@
               </a:defRPr>
             </a:pPr>
             <a:r>
-              <a:t>Sync manual disponible en cualquier momento</a:t>
+              <a:rPr lang="es-ES" noProof="0" dirty="0" err="1"/>
+              <a:t>Sync</a:t>
+            </a:r>
+            <a:r>
+              <a:rPr lang="es-ES" noProof="0" dirty="0"/>
+              <a:t> manual disponible en cualquier momento</a:t>
             </a:r>
           </a:p>
           <a:p>
@@ -4048,7 +4126,8 @@
               </a:defRPr>
             </a:pPr>
             <a:r>
-              <a:t>Resolucion de conflictos: Last-Writer-Wins (LWW)</a:t>
+              <a:rPr lang="es-ES" noProof="0" dirty="0"/>
+              <a:t>Resolución de conflictos: Last-Writer-Wins (LWW)</a:t>
             </a:r>
           </a:p>
           <a:p>
@@ -4064,6 +4143,7 @@
               </a:defRPr>
             </a:pPr>
             <a:r>
+              <a:rPr lang="es-ES" noProof="0" dirty="0"/>
               <a:t>Indicador de estado en tiempo real (Activo/Fallando/Pausado)</a:t>
             </a:r>
           </a:p>
@@ -4080,7 +4160,12 @@
               </a:defRPr>
             </a:pPr>
             <a:r>
-              <a:t>Backend desplegable con Docker en minutos</a:t>
+              <a:rPr lang="es-ES" noProof="0" dirty="0" err="1"/>
+              <a:t>Backend</a:t>
+            </a:r>
+            <a:r>
+              <a:rPr lang="es-ES" noProof="0" dirty="0"/>
+              <a:t> desplegable con Docker en minutos</a:t>
             </a:r>
           </a:p>
           <a:p>
@@ -4096,7 +4181,16 @@
               </a:defRPr>
             </a:pPr>
             <a:r>
-              <a:t>API key como unica autenticacion (simple y seguro)</a:t>
+              <a:rPr lang="es-ES" noProof="0" dirty="0"/>
+              <a:t>API </a:t>
+            </a:r>
+            <a:r>
+              <a:rPr lang="es-ES" noProof="0" dirty="0" err="1"/>
+              <a:t>key</a:t>
+            </a:r>
+            <a:r>
+              <a:rPr lang="es-ES" noProof="0" dirty="0"/>
+              <a:t> como única autenticación (simple y seguro)</a:t>
             </a:r>
           </a:p>
         </p:txBody>
@@ -4130,7 +4224,7 @@
           <a:lstStyle/>
           <a:p>
             <a:r>
-              <a:rPr lang="es-ES" sz="16600" dirty="0"/>
+              <a:rPr lang="es-ES" sz="16600" noProof="0" dirty="0"/>
               <a:t>🔄️</a:t>
             </a:r>
           </a:p>
@@ -4209,7 +4303,7 @@
           <a:lstStyle/>
           <a:p>
             <a:pPr algn="ctr"/>
-            <a:endParaRPr/>
+            <a:endParaRPr lang="es-ES" noProof="0" dirty="0"/>
           </a:p>
         </p:txBody>
       </p:sp>
@@ -4222,7 +4316,7 @@
         <p:spPr>
           <a:xfrm>
             <a:off x="731520" y="457200"/>
-            <a:ext cx="9144000" cy="731520"/>
+            <a:ext cx="9144000" cy="646331"/>
           </a:xfrm>
           <a:prstGeom prst="rect">
             <a:avLst/>
@@ -4244,7 +4338,12 @@
               </a:defRPr>
             </a:pPr>
             <a:r>
-              <a:t>Backups: Tu Informacion Siempre Segura</a:t>
+              <a:rPr lang="es-ES" noProof="0" dirty="0" err="1"/>
+              <a:t>Backups</a:t>
+            </a:r>
+            <a:r>
+              <a:rPr lang="es-ES" noProof="0" dirty="0"/>
+              <a:t>: Tu Información Siempre Segura</a:t>
             </a:r>
           </a:p>
         </p:txBody>
@@ -4258,7 +4357,7 @@
         <p:spPr>
           <a:xfrm>
             <a:off x="731520" y="1280160"/>
-            <a:ext cx="10058400" cy="731520"/>
+            <a:ext cx="10058400" cy="369332"/>
           </a:xfrm>
           <a:prstGeom prst="rect">
             <a:avLst/>
@@ -4280,7 +4379,8 @@
               </a:defRPr>
             </a:pPr>
             <a:r>
-              <a:t>Exporta e importa todos tus datos sin depender de ningun servidor</a:t>
+              <a:rPr lang="es-ES" noProof="0" dirty="0"/>
+              <a:t>Exporta e importa todos tus datos sin depender de ningún servidor</a:t>
             </a:r>
           </a:p>
         </p:txBody>
@@ -4294,7 +4394,7 @@
         <p:spPr>
           <a:xfrm>
             <a:off x="731520" y="2103120"/>
-            <a:ext cx="10058400" cy="4114800"/>
+            <a:ext cx="10058400" cy="2431435"/>
           </a:xfrm>
           <a:prstGeom prst="rect">
             <a:avLst/>
@@ -4319,7 +4419,16 @@
               </a:defRPr>
             </a:pPr>
             <a:r>
-              <a:t>Exportacion completa a archivo .bak (formato JSON portable)</a:t>
+              <a:rPr lang="es-ES" noProof="0" dirty="0"/>
+              <a:t>Exportación completa a archivo .</a:t>
+            </a:r>
+            <a:r>
+              <a:rPr lang="es-ES" noProof="0" dirty="0" err="1"/>
+              <a:t>bak</a:t>
+            </a:r>
+            <a:r>
+              <a:rPr lang="es-ES" noProof="0" dirty="0"/>
+              <a:t> (formato JSON portable)</a:t>
             </a:r>
           </a:p>
           <a:p>
@@ -4335,7 +4444,8 @@
               </a:defRPr>
             </a:pPr>
             <a:r>
-              <a:t>Incluye: eventos, turnos, recordatorios, notificaciones, configuracion</a:t>
+              <a:rPr lang="es-ES" noProof="0" dirty="0"/>
+              <a:t>Incluye: eventos, turnos, recordatorios, notificaciones, configuración</a:t>
             </a:r>
           </a:p>
           <a:p>
@@ -4351,7 +4461,16 @@
               </a:defRPr>
             </a:pPr>
             <a:r>
-              <a:t>Restauracion con merge inteligente (Last-Writer-Wins)</a:t>
+              <a:rPr lang="es-ES" noProof="0" dirty="0"/>
+              <a:t>Restauración con </a:t>
+            </a:r>
+            <a:r>
+              <a:rPr lang="es-ES" noProof="0" dirty="0" err="1"/>
+              <a:t>merge</a:t>
+            </a:r>
+            <a:r>
+              <a:rPr lang="es-ES" noProof="0" dirty="0"/>
+              <a:t> inteligente (Last-Writer-Wins)</a:t>
             </a:r>
           </a:p>
           <a:p>
@@ -4367,7 +4486,16 @@
               </a:defRPr>
             </a:pPr>
             <a:r>
-              <a:t>Cross-platform: crea en web, restaura en Android (y viceversa)</a:t>
+              <a:rPr lang="es-ES" noProof="0" dirty="0"/>
+              <a:t>Cross-</a:t>
+            </a:r>
+            <a:r>
+              <a:rPr lang="es-ES" noProof="0" dirty="0" err="1"/>
+              <a:t>platform</a:t>
+            </a:r>
+            <a:r>
+              <a:rPr lang="es-ES" noProof="0" dirty="0"/>
+              <a:t>: crea en web, restaura en Android (y viceversa)</a:t>
             </a:r>
           </a:p>
           <a:p>
@@ -4383,8 +4511,22 @@
               </a:defRPr>
             </a:pPr>
             <a:r>
-              <a:t>Sin backend necesario para backups</a:t>
-            </a:r>
+              <a:rPr lang="es-ES" noProof="0" dirty="0"/>
+              <a:t>Sin </a:t>
+            </a:r>
+            <a:r>
+              <a:rPr lang="es-ES" noProof="0" dirty="0" err="1"/>
+              <a:t>backend</a:t>
+            </a:r>
+            <a:r>
+              <a:rPr lang="es-ES" noProof="0" dirty="0"/>
+              <a:t> necesario para </a:t>
+            </a:r>
+            <a:r>
+              <a:rPr lang="es-ES" noProof="0" dirty="0" err="1"/>
+              <a:t>backups</a:t>
+            </a:r>
+            <a:endParaRPr lang="es-ES" noProof="0" dirty="0"/>
           </a:p>
           <a:p>
             <a:pPr>
@@ -4399,7 +4541,8 @@
               </a:defRPr>
             </a:pPr>
             <a:r>
-              <a:t>Dialogo de confirmacion antes de sobrescribir datos existentes</a:t>
+              <a:rPr lang="es-ES" noProof="0" dirty="0"/>
+              <a:t>Dialogo de confirmación antes de sobrescribir datos existentes</a:t>
             </a:r>
           </a:p>
           <a:p>
@@ -4415,8 +4558,14 @@
               </a:defRPr>
             </a:pPr>
             <a:r>
-              <a:t>Accesible desde Ajustes &gt; Backups</a:t>
-            </a:r>
+              <a:rPr lang="es-ES" noProof="0" dirty="0"/>
+              <a:t>Accesible desde Ajustes &gt; </a:t>
+            </a:r>
+            <a:r>
+              <a:rPr lang="es-ES" noProof="0" dirty="0" err="1"/>
+              <a:t>Backups</a:t>
+            </a:r>
+            <a:endParaRPr lang="es-ES" noProof="0" dirty="0"/>
           </a:p>
         </p:txBody>
       </p:sp>
@@ -4449,7 +4598,7 @@
           <a:lstStyle/>
           <a:p>
             <a:r>
-              <a:rPr lang="es-ES" sz="16600" dirty="0"/>
+              <a:rPr lang="es-ES" sz="16600" noProof="0" dirty="0"/>
               <a:t>💾</a:t>
             </a:r>
           </a:p>
@@ -4528,7 +4677,7 @@
           <a:lstStyle/>
           <a:p>
             <a:pPr algn="ctr"/>
-            <a:endParaRPr/>
+            <a:endParaRPr lang="es-ES" noProof="0" dirty="0"/>
           </a:p>
         </p:txBody>
       </p:sp>
@@ -4563,6 +4712,7 @@
               </a:defRPr>
             </a:pPr>
             <a:r>
+              <a:rPr lang="es-ES" noProof="0" dirty="0"/>
               <a:t>Multiplataforma: Web + Android</a:t>
             </a:r>
           </a:p>
@@ -4599,6 +4749,7 @@
               </a:defRPr>
             </a:pPr>
             <a:r>
+              <a:rPr lang="es-ES" noProof="0" dirty="0"/>
               <a:t>Web (PWA)</a:t>
             </a:r>
           </a:p>
@@ -4613,7 +4764,7 @@
         <p:spPr>
           <a:xfrm>
             <a:off x="731520" y="2011680"/>
-            <a:ext cx="5029200" cy="4114800"/>
+            <a:ext cx="5029200" cy="2215991"/>
           </a:xfrm>
           <a:prstGeom prst="rect">
             <a:avLst/>
@@ -4638,7 +4789,12 @@
               </a:defRPr>
             </a:pPr>
             <a:r>
-              <a:t>Progressive Web App instalable</a:t>
+              <a:rPr lang="es-ES" noProof="0" dirty="0" err="1"/>
+              <a:t>Progressive</a:t>
+            </a:r>
+            <a:r>
+              <a:rPr lang="es-ES" noProof="0" dirty="0"/>
+              <a:t> Web App instalable</a:t>
             </a:r>
           </a:p>
           <a:p>
@@ -4654,7 +4810,20 @@
               </a:defRPr>
             </a:pPr>
             <a:r>
-              <a:t>React 19 + TypeScript + Vite</a:t>
+              <a:rPr lang="es-ES" noProof="0" dirty="0" err="1"/>
+              <a:t>React</a:t>
+            </a:r>
+            <a:r>
+              <a:rPr lang="es-ES" noProof="0" dirty="0"/>
+              <a:t> 19 + </a:t>
+            </a:r>
+            <a:r>
+              <a:rPr lang="es-ES" noProof="0" dirty="0" err="1"/>
+              <a:t>TypeScript</a:t>
+            </a:r>
+            <a:r>
+              <a:rPr lang="es-ES" noProof="0" dirty="0"/>
+              <a:t> + Vite</a:t>
             </a:r>
           </a:p>
           <a:p>
@@ -4670,6 +4839,7 @@
               </a:defRPr>
             </a:pPr>
             <a:r>
+              <a:rPr lang="es-ES" noProof="0" dirty="0"/>
               <a:t>Funciona en cualquier navegador moderno</a:t>
             </a:r>
           </a:p>
@@ -4686,7 +4856,16 @@
               </a:defRPr>
             </a:pPr>
             <a:r>
-              <a:t>Modo escritorio con sidebar de navegacion</a:t>
+              <a:rPr lang="es-ES" noProof="0" dirty="0"/>
+              <a:t>Modo escritorio con </a:t>
+            </a:r>
+            <a:r>
+              <a:rPr lang="es-ES" noProof="0" dirty="0" err="1"/>
+              <a:t>sidebar</a:t>
+            </a:r>
+            <a:r>
+              <a:rPr lang="es-ES" noProof="0" dirty="0"/>
+              <a:t> de navegación</a:t>
             </a:r>
           </a:p>
           <a:p>
@@ -4702,8 +4881,14 @@
               </a:defRPr>
             </a:pPr>
             <a:r>
-              <a:t>Modo movil con bottom navigation</a:t>
-            </a:r>
+              <a:rPr lang="es-ES" noProof="0" dirty="0"/>
+              <a:t>Modo móvil con bottom </a:t>
+            </a:r>
+            <a:r>
+              <a:rPr lang="es-ES" noProof="0" dirty="0" err="1"/>
+              <a:t>navigation</a:t>
+            </a:r>
+            <a:endParaRPr lang="es-ES" noProof="0" dirty="0"/>
           </a:p>
           <a:p>
             <a:pPr>
@@ -4718,7 +4903,12 @@
               </a:defRPr>
             </a:pPr>
             <a:r>
-              <a:t>IndexedDB para almacenamiento persistente</a:t>
+              <a:rPr lang="es-ES" noProof="0" dirty="0" err="1"/>
+              <a:t>IndexedDB</a:t>
+            </a:r>
+            <a:r>
+              <a:rPr lang="es-ES" noProof="0" dirty="0"/>
+              <a:t> para almacenamiento persistente</a:t>
             </a:r>
           </a:p>
           <a:p>
@@ -4734,7 +4924,8 @@
               </a:defRPr>
             </a:pPr>
             <a:r>
-              <a:t>Tema claro/oscuro + bilingue ES/EN</a:t>
+              <a:rPr lang="es-ES" noProof="0" dirty="0"/>
+              <a:t>Tema claro/oscuro + bilingüe ES/EN</a:t>
             </a:r>
           </a:p>
         </p:txBody>
@@ -4770,6 +4961,7 @@
               </a:defRPr>
             </a:pPr>
             <a:r>
+              <a:rPr lang="es-ES" noProof="0" dirty="0"/>
               <a:t>Android Nativo</a:t>
             </a:r>
           </a:p>
@@ -4809,8 +5001,26 @@
               </a:defRPr>
             </a:pPr>
             <a:r>
-              <a:t>Kotlin + Jetpack Compose</a:t>
-            </a:r>
+              <a:rPr lang="es-ES" noProof="0" dirty="0" err="1"/>
+              <a:t>Kotlin</a:t>
+            </a:r>
+            <a:r>
+              <a:rPr lang="es-ES" noProof="0" dirty="0"/>
+              <a:t> + </a:t>
+            </a:r>
+            <a:r>
+              <a:rPr lang="es-ES" noProof="0" dirty="0" err="1"/>
+              <a:t>Jetpack</a:t>
+            </a:r>
+            <a:r>
+              <a:rPr lang="es-ES" noProof="0" dirty="0"/>
+              <a:t> </a:t>
+            </a:r>
+            <a:r>
+              <a:rPr lang="es-ES" noProof="0" dirty="0" err="1"/>
+              <a:t>Compose</a:t>
+            </a:r>
+            <a:endParaRPr lang="es-ES" noProof="0" dirty="0"/>
           </a:p>
           <a:p>
             <a:pPr>
@@ -4825,7 +5035,16 @@
               </a:defRPr>
             </a:pPr>
             <a:r>
-              <a:t>Material Design 3</a:t>
+              <a:rPr lang="es-ES" noProof="0" dirty="0"/>
+              <a:t>Material </a:t>
+            </a:r>
+            <a:r>
+              <a:rPr lang="es-ES" noProof="0" dirty="0" err="1"/>
+              <a:t>Design</a:t>
+            </a:r>
+            <a:r>
+              <a:rPr lang="es-ES" noProof="0" dirty="0"/>
+              <a:t> 3</a:t>
             </a:r>
           </a:p>
           <a:p>
@@ -4841,6 +5060,7 @@
               </a:defRPr>
             </a:pPr>
             <a:r>
+              <a:rPr lang="es-ES" noProof="0" dirty="0"/>
               <a:t>SQLite + Room para persistencia</a:t>
             </a:r>
           </a:p>
@@ -4857,6 +5077,7 @@
               </a:defRPr>
             </a:pPr>
             <a:r>
+              <a:rPr lang="es-ES" noProof="0" dirty="0"/>
               <a:t>Icono adaptativo con gradiente de marca</a:t>
             </a:r>
           </a:p>
@@ -4873,7 +5094,16 @@
               </a:defRPr>
             </a:pPr>
             <a:r>
-              <a:t>Notificaciones push del sistema</a:t>
+              <a:rPr lang="es-ES" noProof="0" dirty="0"/>
+              <a:t>Notificaciones </a:t>
+            </a:r>
+            <a:r>
+              <a:rPr lang="es-ES" noProof="0" dirty="0" err="1"/>
+              <a:t>push</a:t>
+            </a:r>
+            <a:r>
+              <a:rPr lang="es-ES" noProof="0" dirty="0"/>
+              <a:t> del sistema</a:t>
             </a:r>
           </a:p>
           <a:p>
@@ -4889,6 +5119,7 @@
               </a:defRPr>
             </a:pPr>
             <a:r>
+              <a:rPr lang="es-ES" noProof="0" dirty="0"/>
               <a:t>Cambio de tema e idioma sin reinicio</a:t>
             </a:r>
           </a:p>
@@ -4905,7 +5136,16 @@
               </a:defRPr>
             </a:pPr>
             <a:r>
-              <a:t>Bottom navigation con iconos</a:t>
+              <a:rPr lang="es-ES" noProof="0" dirty="0"/>
+              <a:t>Bottom </a:t>
+            </a:r>
+            <a:r>
+              <a:rPr lang="es-ES" noProof="0" dirty="0" err="1"/>
+              <a:t>navigation</a:t>
+            </a:r>
+            <a:r>
+              <a:rPr lang="es-ES" noProof="0" dirty="0"/>
+              <a:t> con iconos</a:t>
             </a:r>
           </a:p>
         </p:txBody>
@@ -4983,7 +5223,7 @@
           <a:lstStyle/>
           <a:p>
             <a:pPr algn="ctr"/>
-            <a:endParaRPr/>
+            <a:endParaRPr lang="es-ES" noProof="0" dirty="0"/>
           </a:p>
         </p:txBody>
       </p:sp>
@@ -4996,7 +5236,7 @@
         <p:spPr>
           <a:xfrm>
             <a:off x="731520" y="457200"/>
-            <a:ext cx="9144000" cy="731520"/>
+            <a:ext cx="9144000" cy="646331"/>
           </a:xfrm>
           <a:prstGeom prst="rect">
             <a:avLst/>
@@ -5018,7 +5258,8 @@
               </a:defRPr>
             </a:pPr>
             <a:r>
-              <a:t>Diseno Moderno y Accesible</a:t>
+              <a:rPr lang="es-ES" noProof="0" dirty="0"/>
+              <a:t>Diseño Moderno y Accesible</a:t>
             </a:r>
           </a:p>
         </p:txBody>
@@ -5032,7 +5273,7 @@
         <p:spPr>
           <a:xfrm>
             <a:off x="731520" y="1463040"/>
-            <a:ext cx="10058400" cy="5029200"/>
+            <a:ext cx="10058400" cy="3477875"/>
           </a:xfrm>
           <a:prstGeom prst="rect">
             <a:avLst/>
@@ -5057,6 +5298,7 @@
               </a:defRPr>
             </a:pPr>
             <a:r>
+              <a:rPr lang="es-ES" noProof="0" dirty="0"/>
               <a:t>Interfaz limpia y minimalista — sin distracciones</a:t>
             </a:r>
           </a:p>
@@ -5073,7 +5315,8 @@
               </a:defRPr>
             </a:pPr>
             <a:r>
-              <a:t>Tipografia Poppins para maxima legibilidad</a:t>
+              <a:rPr lang="es-ES" noProof="0" dirty="0"/>
+              <a:t>Tipografía Poppins para máxima legibilidad</a:t>
             </a:r>
           </a:p>
           <a:p>
@@ -5089,6 +5332,7 @@
               </a:defRPr>
             </a:pPr>
             <a:r>
+              <a:rPr lang="es-ES" noProof="0" dirty="0"/>
               <a:t>Tema claro y oscuro (cambia al instante, sin reinicio)</a:t>
             </a:r>
           </a:p>
@@ -5105,6 +5349,7 @@
               </a:defRPr>
             </a:pPr>
             <a:r>
+              <a:rPr lang="es-ES" noProof="0" dirty="0"/>
               <a:t>Paleta de colores consistente en ambas plataformas</a:t>
             </a:r>
           </a:p>
@@ -5121,6 +5366,7 @@
               </a:defRPr>
             </a:pPr>
             <a:r>
+              <a:rPr lang="es-ES" noProof="0" dirty="0"/>
               <a:t>Gradiente azul-purpura como identidad visual</a:t>
             </a:r>
           </a:p>
@@ -5137,7 +5383,24 @@
               </a:defRPr>
             </a:pPr>
             <a:r>
-              <a:t>Iconografia uniforme estilo outline (Lucide Icons)</a:t>
+              <a:rPr lang="es-ES" noProof="0" dirty="0"/>
+              <a:t>Iconografía uniforme estilo </a:t>
+            </a:r>
+            <a:r>
+              <a:rPr lang="es-ES" noProof="0" dirty="0" err="1"/>
+              <a:t>outline</a:t>
+            </a:r>
+            <a:r>
+              <a:rPr lang="es-ES" noProof="0" dirty="0"/>
+              <a:t> (Lucide </a:t>
+            </a:r>
+            <a:r>
+              <a:rPr lang="es-ES" noProof="0" dirty="0" err="1"/>
+              <a:t>Icons</a:t>
+            </a:r>
+            <a:r>
+              <a:rPr lang="es-ES" noProof="0" dirty="0"/>
+              <a:t>)</a:t>
             </a:r>
           </a:p>
           <a:p>
@@ -5153,7 +5416,8 @@
               </a:defRPr>
             </a:pPr>
             <a:r>
-              <a:t>Accesibilidad: contraste WCAG AA, navegacion por teclado</a:t>
+              <a:rPr lang="es-ES" noProof="0" dirty="0"/>
+              <a:t>Accesibilidad: contraste WCAG AA, navegación por teclado</a:t>
             </a:r>
           </a:p>
           <a:p>
@@ -5169,7 +5433,16 @@
               </a:defRPr>
             </a:pPr>
             <a:r>
-              <a:t>Responsive: desktop, tablet y movil</a:t>
+              <a:rPr lang="es-ES" noProof="0" dirty="0"/>
+              <a:t>Responsive: desktop, </a:t>
+            </a:r>
+            <a:r>
+              <a:rPr lang="es-ES" noProof="0" dirty="0" err="1"/>
+              <a:t>tablet</a:t>
+            </a:r>
+            <a:r>
+              <a:rPr lang="es-ES" noProof="0" dirty="0"/>
+              <a:t> y móvil</a:t>
             </a:r>
           </a:p>
           <a:p>
@@ -5185,6 +5458,7 @@
               </a:defRPr>
             </a:pPr>
             <a:r>
+              <a:rPr lang="es-ES" noProof="0" dirty="0"/>
               <a:t>Espaciado basado en sistema de 4px</a:t>
             </a:r>
           </a:p>
@@ -5201,6 +5475,7 @@
               </a:defRPr>
             </a:pPr>
             <a:r>
+              <a:rPr lang="es-ES" noProof="0" dirty="0"/>
               <a:t>Tarjetas con indicador de color lateral por tipo de turno</a:t>
             </a:r>
           </a:p>
@@ -5339,7 +5614,7 @@
           <a:lstStyle/>
           <a:p>
             <a:pPr algn="ctr"/>
-            <a:endParaRPr/>
+            <a:endParaRPr lang="es-ES" noProof="0" dirty="0"/>
           </a:p>
         </p:txBody>
       </p:sp>
@@ -5374,6 +5649,7 @@
               </a:defRPr>
             </a:pPr>
             <a:r>
+              <a:rPr lang="es-ES" noProof="0" dirty="0"/>
               <a:t>Notificaciones Inteligentes</a:t>
             </a:r>
           </a:p>
@@ -5410,6 +5686,7 @@
               </a:defRPr>
             </a:pPr>
             <a:r>
+              <a:rPr lang="es-ES" noProof="0" dirty="0"/>
               <a:t>Nunca pierdas un turno o evento importante con alertas configurables</a:t>
             </a:r>
           </a:p>
@@ -5424,7 +5701,7 @@
         <p:spPr>
           <a:xfrm>
             <a:off x="731520" y="2103120"/>
-            <a:ext cx="10058400" cy="4114800"/>
+            <a:ext cx="10058400" cy="3477875"/>
           </a:xfrm>
           <a:prstGeom prst="rect">
             <a:avLst/>
@@ -5449,6 +5726,7 @@
               </a:defRPr>
             </a:pPr>
             <a:r>
+              <a:rPr lang="es-ES" noProof="0" dirty="0"/>
               <a:t>Alertas configurables por evento:</a:t>
             </a:r>
           </a:p>
@@ -5465,6 +5743,7 @@
               </a:defRPr>
             </a:pPr>
             <a:r>
+              <a:rPr lang="es-ES" noProof="0" dirty="0"/>
               <a:t>    - Al inicio del evento</a:t>
             </a:r>
           </a:p>
@@ -5481,6 +5760,7 @@
               </a:defRPr>
             </a:pPr>
             <a:r>
+              <a:rPr lang="es-ES" noProof="0" dirty="0"/>
               <a:t>    - 10 minutos antes</a:t>
             </a:r>
           </a:p>
@@ -5497,6 +5777,7 @@
               </a:defRPr>
             </a:pPr>
             <a:r>
+              <a:rPr lang="es-ES" noProof="0" dirty="0"/>
               <a:t>    - 1 hora antes</a:t>
             </a:r>
           </a:p>
@@ -5513,7 +5794,8 @@
               </a:defRPr>
             </a:pPr>
             <a:r>
-              <a:t>    - 1 dia antes</a:t>
+              <a:rPr lang="es-ES" noProof="0" dirty="0"/>
+              <a:t>    - 1 día antes</a:t>
             </a:r>
           </a:p>
           <a:p>
@@ -5529,7 +5811,24 @@
               </a:defRPr>
             </a:pPr>
             <a:r>
-              <a:t>Canales: in-app, push del sistema, o ambos</a:t>
+              <a:rPr lang="es-ES" noProof="0" dirty="0"/>
+              <a:t>Canales: </a:t>
+            </a:r>
+            <a:r>
+              <a:rPr lang="es-ES" noProof="0" dirty="0" err="1"/>
+              <a:t>in-app</a:t>
+            </a:r>
+            <a:r>
+              <a:rPr lang="es-ES" noProof="0" dirty="0"/>
+              <a:t>, </a:t>
+            </a:r>
+            <a:r>
+              <a:rPr lang="es-ES" noProof="0" dirty="0" err="1"/>
+              <a:t>push</a:t>
+            </a:r>
+            <a:r>
+              <a:rPr lang="es-ES" noProof="0" dirty="0"/>
+              <a:t> del sistema, o ambos</a:t>
             </a:r>
           </a:p>
           <a:p>
@@ -5545,6 +5844,7 @@
               </a:defRPr>
             </a:pPr>
             <a:r>
+              <a:rPr lang="es-ES" noProof="0" dirty="0"/>
               <a:t>Centro de notificaciones accesible desde la campana (top bar)</a:t>
             </a:r>
           </a:p>
@@ -5561,7 +5861,8 @@
               </a:defRPr>
             </a:pPr>
             <a:r>
-              <a:t>Marcar todas como leidas con un toque</a:t>
+              <a:rPr lang="es-ES" noProof="0" dirty="0"/>
+              <a:t>Marcar todas como leídas con un toque</a:t>
             </a:r>
           </a:p>
           <a:p>
@@ -5577,7 +5878,8 @@
               </a:defRPr>
             </a:pPr>
             <a:r>
-              <a:t>Limpieza automatica de notificaciones pasadas</a:t>
+              <a:rPr lang="es-ES" noProof="0" dirty="0"/>
+              <a:t>Limpieza automática de notificaciones pasadas</a:t>
             </a:r>
           </a:p>
           <a:p>
@@ -5593,7 +5895,8 @@
               </a:defRPr>
             </a:pPr>
             <a:r>
-              <a:t>Configuracion global en Ajustes &gt; Notificaciones</a:t>
+              <a:rPr lang="es-ES" noProof="0" dirty="0"/>
+              <a:t>Configuración global en Ajustes &gt; Notificaciones</a:t>
             </a:r>
           </a:p>
         </p:txBody>
@@ -5627,7 +5930,7 @@
           <a:lstStyle/>
           <a:p>
             <a:r>
-              <a:rPr lang="es-ES" sz="16600" dirty="0"/>
+              <a:rPr lang="es-ES" sz="16600" noProof="0" dirty="0"/>
               <a:t>🔔</a:t>
             </a:r>
           </a:p>
@@ -5706,7 +6009,7 @@
           <a:lstStyle/>
           <a:p>
             <a:pPr algn="ctr"/>
-            <a:endParaRPr/>
+            <a:endParaRPr lang="es-ES" noProof="0" dirty="0"/>
           </a:p>
         </p:txBody>
       </p:sp>
@@ -5741,6 +6044,7 @@
               </a:defRPr>
             </a:pPr>
             <a:r>
+              <a:rPr lang="es-ES" noProof="0" dirty="0"/>
               <a:t>Personalizable a Tu Medida</a:t>
             </a:r>
           </a:p>
@@ -5755,7 +6059,7 @@
         <p:spPr>
           <a:xfrm>
             <a:off x="731520" y="1463040"/>
-            <a:ext cx="10058400" cy="5029200"/>
+            <a:ext cx="10058400" cy="2780248"/>
           </a:xfrm>
           <a:prstGeom prst="rect">
             <a:avLst/>
@@ -5780,6 +6084,7 @@
               </a:defRPr>
             </a:pPr>
             <a:r>
+              <a:rPr lang="es-ES" noProof="0" dirty="0"/>
               <a:t>Tema: Claro, Oscuro o Sistema (se aplica al instante)</a:t>
             </a:r>
           </a:p>
@@ -5796,7 +6101,8 @@
               </a:defRPr>
             </a:pPr>
             <a:r>
-              <a:t>Idioma: Espanol / Ingles (cambio inmediato sin reinicio)</a:t>
+              <a:rPr lang="es-ES" noProof="0" dirty="0"/>
+              <a:t>Idioma: Español / Ingles (cambio inmediato sin reinicio)</a:t>
             </a:r>
           </a:p>
           <a:p>
@@ -5812,7 +6118,8 @@
               </a:defRPr>
             </a:pPr>
             <a:r>
-              <a:t>Intervalo de sincronizacion personalizable (5-60 min)</a:t>
+              <a:rPr lang="es-ES" noProof="0" dirty="0"/>
+              <a:t>Intervalo de sincronización personalizable (5-60 min)</a:t>
             </a:r>
           </a:p>
           <a:p>
@@ -5828,7 +6135,8 @@
               </a:defRPr>
             </a:pPr>
             <a:r>
-              <a:t>Configuracion de canal de notificaciones</a:t>
+              <a:rPr lang="es-ES" noProof="0" dirty="0"/>
+              <a:t>Configuración de canal de notificaciones</a:t>
             </a:r>
           </a:p>
           <a:p>
@@ -5844,7 +6152,8 @@
               </a:defRPr>
             </a:pPr>
             <a:r>
-              <a:t>Servidor de sincronizacion con URL personalizable</a:t>
+              <a:rPr lang="es-ES" noProof="0" dirty="0"/>
+              <a:t>Servidor de sincronización con URL personalizable</a:t>
             </a:r>
           </a:p>
           <a:p>
@@ -5860,7 +6169,12 @@
               </a:defRPr>
             </a:pPr>
             <a:r>
-              <a:t>Backups manuales y restauracion</a:t>
+              <a:rPr lang="es-ES" noProof="0" dirty="0" err="1"/>
+              <a:t>Backups</a:t>
+            </a:r>
+            <a:r>
+              <a:rPr lang="es-ES" noProof="0" dirty="0"/>
+              <a:t> manuales y restauración</a:t>
             </a:r>
           </a:p>
           <a:p>
@@ -5876,7 +6190,12 @@
               </a:defRPr>
             </a:pPr>
             <a:r>
-              <a:t>Reset de aplicacion (zona de peligro) para limpiar datos</a:t>
+              <a:rPr lang="es-ES" noProof="0" dirty="0" err="1"/>
+              <a:t>Reset</a:t>
+            </a:r>
+            <a:r>
+              <a:rPr lang="es-ES" noProof="0" dirty="0"/>
+              <a:t> de aplicación (zona de peligro) para limpiar datos</a:t>
             </a:r>
           </a:p>
           <a:p>
@@ -5892,6 +6211,7 @@
               </a:defRPr>
             </a:pPr>
             <a:r>
+              <a:rPr lang="es-ES" noProof="0" dirty="0"/>
               <a:t>Todas las preferencias persisten localmente</a:t>
             </a:r>
           </a:p>
@@ -6000,7 +6320,7 @@
           <a:lstStyle/>
           <a:p>
             <a:pPr algn="ctr"/>
-            <a:endParaRPr/>
+            <a:endParaRPr lang="es-ES" noProof="0" dirty="0"/>
           </a:p>
         </p:txBody>
       </p:sp>
@@ -6035,8 +6355,14 @@
               </a:defRPr>
             </a:pPr>
             <a:r>
-              <a:t>Arquitectura y Tecnologia</a:t>
-            </a:r>
+              <a:rPr lang="es-ES" noProof="0" dirty="0"/>
+              <a:t>Arquitectura y </a:t>
+            </a:r>
+            <a:r>
+              <a:rPr lang="es-ES" noProof="0" dirty="0" err="1"/>
+              <a:t>Tecnologia</a:t>
+            </a:r>
+            <a:endParaRPr lang="es-ES" noProof="0" dirty="0"/>
           </a:p>
         </p:txBody>
       </p:sp>
@@ -6071,7 +6397,12 @@
               </a:defRPr>
             </a:pPr>
             <a:r>
-              <a:t>Backend (API)</a:t>
+              <a:rPr lang="es-ES" noProof="0" dirty="0" err="1"/>
+              <a:t>Backend</a:t>
+            </a:r>
+            <a:r>
+              <a:rPr lang="es-ES" noProof="0" dirty="0"/>
+              <a:t> (API)</a:t>
             </a:r>
           </a:p>
         </p:txBody>
@@ -6110,6 +6441,7 @@
               </a:defRPr>
             </a:pPr>
             <a:r>
+              <a:rPr lang="es-ES" noProof="0" dirty="0"/>
               <a:t>.NET 10 (C#)</a:t>
             </a:r>
           </a:p>
@@ -6126,6 +6458,7 @@
               </a:defRPr>
             </a:pPr>
             <a:r>
+              <a:rPr lang="es-ES" noProof="0" dirty="0"/>
               <a:t>REST API + Docker</a:t>
             </a:r>
           </a:p>
@@ -6142,6 +6475,7 @@
               </a:defRPr>
             </a:pPr>
             <a:r>
+              <a:rPr lang="es-ES" noProof="0" dirty="0"/>
               <a:t>MySQL / EF Core</a:t>
             </a:r>
           </a:p>
@@ -6158,8 +6492,14 @@
               </a:defRPr>
             </a:pPr>
             <a:r>
-              <a:t>API Key auth</a:t>
-            </a:r>
+              <a:rPr lang="es-ES" noProof="0" dirty="0"/>
+              <a:t>API Key </a:t>
+            </a:r>
+            <a:r>
+              <a:rPr lang="es-ES" noProof="0" dirty="0" err="1"/>
+              <a:t>auth</a:t>
+            </a:r>
+            <a:endParaRPr lang="es-ES" noProof="0" dirty="0"/>
           </a:p>
           <a:p>
             <a:pPr>
@@ -6174,8 +6514,10 @@
               </a:defRPr>
             </a:pPr>
             <a:r>
+              <a:rPr lang="es-ES" noProof="0" dirty="0" err="1"/>
               <a:t>Auto-hospedable</a:t>
             </a:r>
+            <a:endParaRPr lang="es-ES" noProof="0" dirty="0"/>
           </a:p>
         </p:txBody>
       </p:sp>
@@ -6210,6 +6552,7 @@
               </a:defRPr>
             </a:pPr>
             <a:r>
+              <a:rPr lang="es-ES" noProof="0" dirty="0"/>
               <a:t>Web (PWA)</a:t>
             </a:r>
           </a:p>
@@ -6249,8 +6592,18 @@
               </a:defRPr>
             </a:pPr>
             <a:r>
-              <a:t>React 19 + TypeScript</a:t>
-            </a:r>
+              <a:rPr lang="es-ES" noProof="0" dirty="0" err="1"/>
+              <a:t>React</a:t>
+            </a:r>
+            <a:r>
+              <a:rPr lang="es-ES" noProof="0" dirty="0"/>
+              <a:t> 19 + </a:t>
+            </a:r>
+            <a:r>
+              <a:rPr lang="es-ES" noProof="0" dirty="0" err="1"/>
+              <a:t>TypeScript</a:t>
+            </a:r>
+            <a:endParaRPr lang="es-ES" noProof="0" dirty="0"/>
           </a:p>
           <a:p>
             <a:pPr>
@@ -6265,7 +6618,16 @@
               </a:defRPr>
             </a:pPr>
             <a:r>
-              <a:t>Vite + Tailwind CSS v4</a:t>
+              <a:rPr lang="es-ES" noProof="0" dirty="0"/>
+              <a:t>Vite + </a:t>
+            </a:r>
+            <a:r>
+              <a:rPr lang="es-ES" noProof="0" dirty="0" err="1"/>
+              <a:t>Tailwind</a:t>
+            </a:r>
+            <a:r>
+              <a:rPr lang="es-ES" noProof="0" dirty="0"/>
+              <a:t> CSS v4</a:t>
             </a:r>
           </a:p>
           <a:p>
@@ -6281,7 +6643,12 @@
               </a:defRPr>
             </a:pPr>
             <a:r>
-              <a:t>IndexedDB offline</a:t>
+              <a:rPr lang="es-ES" noProof="0" dirty="0" err="1"/>
+              <a:t>IndexedDB</a:t>
+            </a:r>
+            <a:r>
+              <a:rPr lang="es-ES" noProof="0" dirty="0"/>
+              <a:t> offline</a:t>
             </a:r>
           </a:p>
           <a:p>
@@ -6297,7 +6664,20 @@
               </a:defRPr>
             </a:pPr>
             <a:r>
-              <a:t>React Router + Query</a:t>
+              <a:rPr lang="es-ES" noProof="0" dirty="0" err="1"/>
+              <a:t>React</a:t>
+            </a:r>
+            <a:r>
+              <a:rPr lang="es-ES" noProof="0" dirty="0"/>
+              <a:t> </a:t>
+            </a:r>
+            <a:r>
+              <a:rPr lang="es-ES" noProof="0" dirty="0" err="1"/>
+              <a:t>Router</a:t>
+            </a:r>
+            <a:r>
+              <a:rPr lang="es-ES" noProof="0" dirty="0"/>
+              <a:t> + Query</a:t>
             </a:r>
           </a:p>
           <a:p>
@@ -6313,8 +6693,18 @@
               </a:defRPr>
             </a:pPr>
             <a:r>
-              <a:t>Vitest + Playwright</a:t>
-            </a:r>
+              <a:rPr lang="es-ES" noProof="0" dirty="0" err="1"/>
+              <a:t>Vitest</a:t>
+            </a:r>
+            <a:r>
+              <a:rPr lang="es-ES" noProof="0" dirty="0"/>
+              <a:t> + </a:t>
+            </a:r>
+            <a:r>
+              <a:rPr lang="es-ES" noProof="0" dirty="0" err="1"/>
+              <a:t>Playwright</a:t>
+            </a:r>
+            <a:endParaRPr lang="es-ES" noProof="0" dirty="0"/>
           </a:p>
         </p:txBody>
       </p:sp>
@@ -6349,6 +6739,7 @@
               </a:defRPr>
             </a:pPr>
             <a:r>
+              <a:rPr lang="es-ES" noProof="0" dirty="0"/>
               <a:t>Android</a:t>
             </a:r>
           </a:p>
@@ -6388,8 +6779,18 @@
               </a:defRPr>
             </a:pPr>
             <a:r>
-              <a:t>Kotlin + Compose</a:t>
-            </a:r>
+              <a:rPr lang="es-ES" noProof="0" dirty="0" err="1"/>
+              <a:t>Kotlin</a:t>
+            </a:r>
+            <a:r>
+              <a:rPr lang="es-ES" noProof="0" dirty="0"/>
+              <a:t> + </a:t>
+            </a:r>
+            <a:r>
+              <a:rPr lang="es-ES" noProof="0" dirty="0" err="1"/>
+              <a:t>Compose</a:t>
+            </a:r>
+            <a:endParaRPr lang="es-ES" noProof="0" dirty="0"/>
           </a:p>
           <a:p>
             <a:pPr>
@@ -6404,7 +6805,16 @@
               </a:defRPr>
             </a:pPr>
             <a:r>
-              <a:t>Material Design 3</a:t>
+              <a:rPr lang="es-ES" noProof="0" dirty="0"/>
+              <a:t>Material </a:t>
+            </a:r>
+            <a:r>
+              <a:rPr lang="es-ES" noProof="0" dirty="0" err="1"/>
+              <a:t>Design</a:t>
+            </a:r>
+            <a:r>
+              <a:rPr lang="es-ES" noProof="0" dirty="0"/>
+              <a:t> 3</a:t>
             </a:r>
           </a:p>
           <a:p>
@@ -6420,6 +6830,7 @@
               </a:defRPr>
             </a:pPr>
             <a:r>
+              <a:rPr lang="es-ES" noProof="0" dirty="0"/>
               <a:t>Room (SQLite)</a:t>
             </a:r>
           </a:p>
@@ -6436,8 +6847,18 @@
               </a:defRPr>
             </a:pPr>
             <a:r>
-              <a:t>Retrofit + OkHttp</a:t>
-            </a:r>
+              <a:rPr lang="es-ES" noProof="0" dirty="0" err="1"/>
+              <a:t>Retrofit</a:t>
+            </a:r>
+            <a:r>
+              <a:rPr lang="es-ES" noProof="0" dirty="0"/>
+              <a:t> + </a:t>
+            </a:r>
+            <a:r>
+              <a:rPr lang="es-ES" noProof="0" dirty="0" err="1"/>
+              <a:t>OkHttp</a:t>
+            </a:r>
+            <a:endParaRPr lang="es-ES" noProof="0" dirty="0"/>
           </a:p>
           <a:p>
             <a:pPr>
@@ -6452,8 +6873,18 @@
               </a:defRPr>
             </a:pPr>
             <a:r>
-              <a:t>DataStore prefs</a:t>
-            </a:r>
+              <a:rPr lang="es-ES" noProof="0" dirty="0" err="1"/>
+              <a:t>DataStore</a:t>
+            </a:r>
+            <a:r>
+              <a:rPr lang="es-ES" noProof="0" dirty="0"/>
+              <a:t> </a:t>
+            </a:r>
+            <a:r>
+              <a:rPr lang="es-ES" noProof="0" dirty="0" err="1"/>
+              <a:t>prefs</a:t>
+            </a:r>
+            <a:endParaRPr lang="es-ES" noProof="0" dirty="0"/>
           </a:p>
         </p:txBody>
       </p:sp>
@@ -6466,7 +6897,7 @@
         <p:spPr>
           <a:xfrm>
             <a:off x="731520" y="5669280"/>
-            <a:ext cx="10058400" cy="548640"/>
+            <a:ext cx="10058400" cy="307777"/>
           </a:xfrm>
           <a:prstGeom prst="rect">
             <a:avLst/>
@@ -6488,7 +6919,32 @@
               </a:defRPr>
             </a:pPr>
             <a:r>
-              <a:t>Arquitectura offline-first: los clientes operan independientemente. El backend es solo un hub de sincronizacion opcional.</a:t>
+              <a:rPr lang="es-ES" noProof="0" dirty="0"/>
+              <a:t>Arquitectura offline-</a:t>
+            </a:r>
+            <a:r>
+              <a:rPr lang="es-ES" noProof="0" dirty="0" err="1"/>
+              <a:t>first</a:t>
+            </a:r>
+            <a:r>
+              <a:rPr lang="es-ES" noProof="0" dirty="0"/>
+              <a:t>: los clientes operan independientemente. El </a:t>
+            </a:r>
+            <a:r>
+              <a:rPr lang="es-ES" noProof="0" dirty="0" err="1"/>
+              <a:t>backend</a:t>
+            </a:r>
+            <a:r>
+              <a:rPr lang="es-ES" noProof="0" dirty="0"/>
+              <a:t> es solo un </a:t>
+            </a:r>
+            <a:r>
+              <a:rPr lang="es-ES" noProof="0" dirty="0" err="1"/>
+              <a:t>hub</a:t>
+            </a:r>
+            <a:r>
+              <a:rPr lang="es-ES" noProof="0" dirty="0"/>
+              <a:t> de sincronización opcional.</a:t>
             </a:r>
           </a:p>
         </p:txBody>
@@ -6656,7 +7112,7 @@
           <a:lstStyle/>
           <a:p>
             <a:pPr algn="ctr"/>
-            <a:endParaRPr/>
+            <a:endParaRPr lang="es-ES" noProof="0" dirty="0"/>
           </a:p>
         </p:txBody>
       </p:sp>
@@ -6691,6 +7147,7 @@
               </a:defRPr>
             </a:pPr>
             <a:r>
+              <a:rPr lang="es-ES" noProof="0" dirty="0"/>
               <a:t>Para Quien es Planixor?</a:t>
             </a:r>
           </a:p>
@@ -6705,7 +7162,7 @@
         <p:spPr>
           <a:xfrm>
             <a:off x="731520" y="1463040"/>
-            <a:ext cx="10058400" cy="3657600"/>
+            <a:ext cx="10058400" cy="2646878"/>
           </a:xfrm>
           <a:prstGeom prst="rect">
             <a:avLst/>
@@ -6730,7 +7187,8 @@
               </a:defRPr>
             </a:pPr>
             <a:r>
-              <a:t>Profesionales con turnos rotativos (salud, seguridad, hosteleria)</a:t>
+              <a:rPr lang="es-ES" noProof="0" dirty="0"/>
+              <a:t>Profesionales con turnos rotativos (salud, seguridad, hostelería)</a:t>
             </a:r>
           </a:p>
           <a:p>
@@ -6746,7 +7204,12 @@
               </a:defRPr>
             </a:pPr>
             <a:r>
-              <a:t>Freelancers que necesitan control de horas trabajadas</a:t>
+              <a:rPr lang="es-ES" noProof="0" dirty="0" err="1"/>
+              <a:t>Freelancers</a:t>
+            </a:r>
+            <a:r>
+              <a:rPr lang="es-ES" noProof="0" dirty="0"/>
+              <a:t> que necesitan control de horas trabajadas</a:t>
             </a:r>
           </a:p>
           <a:p>
@@ -6762,7 +7225,8 @@
               </a:defRPr>
             </a:pPr>
             <a:r>
-              <a:t>Equipos pequenos que comparten horarios</a:t>
+              <a:rPr lang="es-ES" noProof="0" dirty="0"/>
+              <a:t>Equipos pequeños que comparten horarios</a:t>
             </a:r>
           </a:p>
           <a:p>
@@ -6778,6 +7242,7 @@
               </a:defRPr>
             </a:pPr>
             <a:r>
+              <a:rPr lang="es-ES" noProof="0" dirty="0"/>
               <a:t>Personas preocupadas por la privacidad de sus datos</a:t>
             </a:r>
           </a:p>
@@ -6794,6 +7259,7 @@
               </a:defRPr>
             </a:pPr>
             <a:r>
+              <a:rPr lang="es-ES" noProof="0" dirty="0"/>
               <a:t>Usuarios en zonas con conectividad limitada</a:t>
             </a:r>
           </a:p>
@@ -6810,7 +7276,16 @@
               </a:defRPr>
             </a:pPr>
             <a:r>
-              <a:t>Organizaciones que prefieren infraestructura propia (self-hosted)</a:t>
+              <a:rPr lang="es-ES" noProof="0" dirty="0"/>
+              <a:t>Organizaciones que prefieren infraestructura propia (</a:t>
+            </a:r>
+            <a:r>
+              <a:rPr lang="es-ES" noProof="0" dirty="0" err="1"/>
+              <a:t>self-hosted</a:t>
+            </a:r>
+            <a:r>
+              <a:rPr lang="es-ES" noProof="0" dirty="0"/>
+              <a:t>)</a:t>
             </a:r>
           </a:p>
           <a:p>
@@ -6826,6 +7301,7 @@
               </a:defRPr>
             </a:pPr>
             <a:r>
+              <a:rPr lang="es-ES" noProof="0" dirty="0"/>
               <a:t>Cualquiera que quiera unificar turnos + calendario + recordatorios</a:t>
             </a:r>
           </a:p>
@@ -6862,6 +7338,7 @@
               </a:defRPr>
             </a:pPr>
             <a:r>
+              <a:rPr lang="es-ES" noProof="0" dirty="0"/>
               <a:t>"Si trabajas por turnos y valoras tu privacidad, Planixor es tu herramienta."</a:t>
             </a:r>
           </a:p>
@@ -6970,7 +7447,7 @@
           <a:lstStyle/>
           <a:p>
             <a:pPr algn="ctr"/>
-            <a:endParaRPr/>
+            <a:endParaRPr lang="es-ES" noProof="0" dirty="0"/>
           </a:p>
         </p:txBody>
       </p:sp>
@@ -7005,6 +7482,7 @@
               </a:defRPr>
             </a:pPr>
             <a:r>
+              <a:rPr lang="es-ES" noProof="0" dirty="0"/>
               <a:t>Ventajas Competitivas</a:t>
             </a:r>
           </a:p>
@@ -7041,6 +7519,7 @@
               </a:defRPr>
             </a:pPr>
             <a:r>
+              <a:rPr lang="es-ES" noProof="0" dirty="0"/>
               <a:t>Planixor</a:t>
             </a:r>
           </a:p>
@@ -7077,8 +7556,14 @@
               </a:defRPr>
             </a:pPr>
             <a:r>
-              <a:t>Competencia tipica</a:t>
-            </a:r>
+              <a:rPr lang="es-ES" noProof="0" dirty="0"/>
+              <a:t>Competencia </a:t>
+            </a:r>
+            <a:r>
+              <a:rPr lang="es-ES" noProof="0" dirty="0" err="1"/>
+              <a:t>tipica</a:t>
+            </a:r>
+            <a:endParaRPr lang="es-ES" noProof="0" dirty="0"/>
           </a:p>
         </p:txBody>
       </p:sp>
@@ -7091,7 +7576,7 @@
         <p:spPr>
           <a:xfrm>
             <a:off x="731520" y="1920240"/>
-            <a:ext cx="5029200" cy="4114800"/>
+            <a:ext cx="5029200" cy="2215991"/>
           </a:xfrm>
           <a:prstGeom prst="rect">
             <a:avLst/>
@@ -7116,6 +7601,7 @@
               </a:defRPr>
             </a:pPr>
             <a:r>
+              <a:rPr lang="es-ES" noProof="0" dirty="0"/>
               <a:t>100% offline, sin dependencia de internet</a:t>
             </a:r>
           </a:p>
@@ -7132,6 +7618,7 @@
               </a:defRPr>
             </a:pPr>
             <a:r>
+              <a:rPr lang="es-ES" noProof="0" dirty="0"/>
               <a:t>Datos solo en tu dispositivo</a:t>
             </a:r>
           </a:p>
@@ -7148,7 +7635,20 @@
               </a:defRPr>
             </a:pPr>
             <a:r>
-              <a:t>Sync con TU servidor (self-hosted)</a:t>
+              <a:rPr lang="es-ES" noProof="0" dirty="0" err="1"/>
+              <a:t>Sync</a:t>
+            </a:r>
+            <a:r>
+              <a:rPr lang="es-ES" noProof="0" dirty="0"/>
+              <a:t> con TU servidor (</a:t>
+            </a:r>
+            <a:r>
+              <a:rPr lang="es-ES" noProof="0" dirty="0" err="1"/>
+              <a:t>self-hosted</a:t>
+            </a:r>
+            <a:r>
+              <a:rPr lang="es-ES" noProof="0" dirty="0"/>
+              <a:t>)</a:t>
             </a:r>
           </a:p>
           <a:p>
@@ -7164,7 +7664,8 @@
               </a:defRPr>
             </a:pPr>
             <a:r>
-              <a:t>Sin suscripcion mensual para nube</a:t>
+              <a:rPr lang="es-ES" noProof="0" dirty="0"/>
+              <a:t>Sin suscripción mensual para nube</a:t>
             </a:r>
           </a:p>
           <a:p>
@@ -7180,7 +7681,8 @@
               </a:defRPr>
             </a:pPr>
             <a:r>
-              <a:t>Codigo multiplataforma (web + Android)</a:t>
+              <a:rPr lang="es-ES" noProof="0" dirty="0"/>
+              <a:t>Código multiplataforma (web + Android)</a:t>
             </a:r>
           </a:p>
           <a:p>
@@ -7196,8 +7698,22 @@
               </a:defRPr>
             </a:pPr>
             <a:r>
-              <a:t>Open-source / auto-desplegable</a:t>
-            </a:r>
+              <a:rPr lang="es-ES" noProof="0" dirty="0"/>
+              <a:t>Open-</a:t>
+            </a:r>
+            <a:r>
+              <a:rPr lang="es-ES" noProof="0" dirty="0" err="1"/>
+              <a:t>source</a:t>
+            </a:r>
+            <a:r>
+              <a:rPr lang="es-ES" noProof="0" dirty="0"/>
+              <a:t> / </a:t>
+            </a:r>
+            <a:r>
+              <a:rPr lang="es-ES" noProof="0" dirty="0" err="1"/>
+              <a:t>auto-desplegable</a:t>
+            </a:r>
+            <a:endParaRPr lang="es-ES" noProof="0" dirty="0"/>
           </a:p>
           <a:p>
             <a:pPr>
@@ -7212,7 +7728,16 @@
               </a:defRPr>
             </a:pPr>
             <a:r>
-              <a:t>Privacidad por diseno (GDPR friendly)</a:t>
+              <a:rPr lang="es-ES" noProof="0" dirty="0"/>
+              <a:t>Privacidad por diseño (GDPR </a:t>
+            </a:r>
+            <a:r>
+              <a:rPr lang="es-ES" noProof="0" dirty="0" err="1"/>
+              <a:t>friendly</a:t>
+            </a:r>
+            <a:r>
+              <a:rPr lang="es-ES" noProof="0" dirty="0"/>
+              <a:t>)</a:t>
             </a:r>
           </a:p>
         </p:txBody>
@@ -7226,7 +7751,7 @@
         <p:spPr>
           <a:xfrm>
             <a:off x="6400800" y="1920240"/>
-            <a:ext cx="5029200" cy="4114800"/>
+            <a:ext cx="5029200" cy="2215991"/>
           </a:xfrm>
           <a:prstGeom prst="rect">
             <a:avLst/>
@@ -7251,6 +7776,7 @@
               </a:defRPr>
             </a:pPr>
             <a:r>
+              <a:rPr lang="es-ES" noProof="0" dirty="0"/>
               <a:t>Requiere internet para funcionar</a:t>
             </a:r>
           </a:p>
@@ -7267,6 +7793,7 @@
               </a:defRPr>
             </a:pPr>
             <a:r>
+              <a:rPr lang="es-ES" noProof="0" dirty="0"/>
               <a:t>Datos en servidores de terceros</a:t>
             </a:r>
           </a:p>
@@ -7283,7 +7810,12 @@
               </a:defRPr>
             </a:pPr>
             <a:r>
-              <a:t>Sync con servidores del proveedor</a:t>
+              <a:rPr lang="es-ES" noProof="0" dirty="0" err="1"/>
+              <a:t>Sync</a:t>
+            </a:r>
+            <a:r>
+              <a:rPr lang="es-ES" noProof="0" dirty="0"/>
+              <a:t> con servidores del proveedor</a:t>
             </a:r>
           </a:p>
           <a:p>
@@ -7299,6 +7831,7 @@
               </a:defRPr>
             </a:pPr>
             <a:r>
+              <a:rPr lang="es-ES" noProof="0" dirty="0"/>
               <a:t>Suscripciones de $5-15/mes</a:t>
             </a:r>
           </a:p>
@@ -7315,7 +7848,8 @@
               </a:defRPr>
             </a:pPr>
             <a:r>
-              <a:t>Solo una plataforma o web basica</a:t>
+              <a:rPr lang="es-ES" noProof="0" dirty="0"/>
+              <a:t>Solo una plataforma o web básica</a:t>
             </a:r>
           </a:p>
           <a:p>
@@ -7331,6 +7865,7 @@
               </a:defRPr>
             </a:pPr>
             <a:r>
+              <a:rPr lang="es-ES" noProof="0" dirty="0"/>
               <a:t>SaaS cerrado, sin control</a:t>
             </a:r>
           </a:p>
@@ -7347,7 +7882,8 @@
               </a:defRPr>
             </a:pPr>
             <a:r>
-              <a:t>Politicas de privacidad ambiguas</a:t>
+              <a:rPr lang="es-ES" noProof="0" dirty="0"/>
+              <a:t>Políticas de privacidad ambiguas</a:t>
             </a:r>
           </a:p>
         </p:txBody>
@@ -7432,7 +7968,7 @@
           <a:lstStyle/>
           <a:p>
             <a:pPr algn="ctr"/>
-            <a:endParaRPr lang="es-ES"/>
+            <a:endParaRPr lang="es-ES" noProof="0" dirty="0"/>
           </a:p>
         </p:txBody>
       </p:sp>
@@ -7476,7 +8012,7 @@
           <a:lstStyle/>
           <a:p>
             <a:pPr algn="ctr"/>
-            <a:endParaRPr/>
+            <a:endParaRPr lang="es-ES" noProof="0" dirty="0"/>
           </a:p>
         </p:txBody>
       </p:sp>
@@ -7542,80 +8078,8 @@
               </a:defRPr>
             </a:pPr>
             <a:r>
-              <a:rPr sz="2400" dirty="0"/>
-              <a:t>Los </a:t>
-            </a:r>
-            <a:r>
-              <a:rPr sz="2400" dirty="0" err="1"/>
-              <a:t>profesionales</a:t>
-            </a:r>
-            <a:r>
-              <a:rPr sz="2400" dirty="0"/>
-              <a:t> </a:t>
-            </a:r>
-            <a:r>
-              <a:rPr sz="2400" dirty="0" err="1"/>
-              <a:t>necesitan</a:t>
-            </a:r>
-            <a:r>
-              <a:rPr sz="2400" dirty="0"/>
-              <a:t> </a:t>
-            </a:r>
-            <a:r>
-              <a:rPr sz="2400" dirty="0" err="1"/>
-              <a:t>una</a:t>
-            </a:r>
-            <a:r>
-              <a:rPr sz="2400" dirty="0"/>
-              <a:t> </a:t>
-            </a:r>
-            <a:r>
-              <a:rPr sz="2400" dirty="0" err="1"/>
-              <a:t>herramienta</a:t>
-            </a:r>
-            <a:r>
-              <a:rPr sz="2400" dirty="0"/>
-              <a:t> </a:t>
-            </a:r>
-            <a:r>
-              <a:rPr sz="2400" dirty="0" err="1"/>
-              <a:t>unificada</a:t>
-            </a:r>
-            <a:r>
-              <a:rPr sz="2400" dirty="0"/>
-              <a:t>, </a:t>
-            </a:r>
-            <a:r>
-              <a:rPr sz="2400" dirty="0" err="1"/>
-              <a:t>privada</a:t>
-            </a:r>
-            <a:r>
-              <a:rPr sz="2400" dirty="0"/>
-              <a:t> y </a:t>
-            </a:r>
-            <a:r>
-              <a:rPr sz="2400" dirty="0" err="1"/>
-              <a:t>que</a:t>
-            </a:r>
-            <a:r>
-              <a:rPr sz="2400" dirty="0"/>
-              <a:t> </a:t>
-            </a:r>
-            <a:r>
-              <a:rPr sz="2400" dirty="0" err="1"/>
-              <a:t>funcione</a:t>
-            </a:r>
-            <a:r>
-              <a:rPr sz="2400" dirty="0"/>
-              <a:t> </a:t>
-            </a:r>
-            <a:r>
-              <a:rPr sz="2400" dirty="0" err="1"/>
-              <a:t>siempre</a:t>
-            </a:r>
-            <a:r>
-              <a:rPr sz="2400" dirty="0"/>
-              <a:t>.</a:t>
+              <a:rPr lang="es-ES" sz="2400" noProof="0" dirty="0"/>
+              <a:t>Los profesionales necesitan una herramienta unificada, privada y que funcione siempre.</a:t>
             </a:r>
           </a:p>
         </p:txBody>
@@ -7693,7 +8157,7 @@
           <a:lstStyle/>
           <a:p>
             <a:pPr algn="ctr"/>
-            <a:endParaRPr/>
+            <a:endParaRPr lang="es-ES" noProof="0" dirty="0"/>
           </a:p>
         </p:txBody>
       </p:sp>
@@ -7728,6 +8192,7 @@
               </a:defRPr>
             </a:pPr>
             <a:r>
+              <a:rPr lang="es-ES" noProof="0" dirty="0"/>
               <a:t>Planixor</a:t>
             </a:r>
           </a:p>
@@ -7742,7 +8207,7 @@
         <p:spPr>
           <a:xfrm>
             <a:off x="2286000" y="2560320"/>
-            <a:ext cx="7772400" cy="731520"/>
+            <a:ext cx="7772400" cy="523220"/>
           </a:xfrm>
           <a:prstGeom prst="rect">
             <a:avLst/>
@@ -7764,7 +8229,8 @@
               </a:defRPr>
             </a:pPr>
             <a:r>
-              <a:t>Organiza tu tiempo. Potencia tu dia.</a:t>
+              <a:rPr lang="es-ES" noProof="0" dirty="0"/>
+              <a:t>Organiza tu tiempo. Potencia tu día.</a:t>
             </a:r>
           </a:p>
         </p:txBody>
@@ -7816,18 +8282,9 @@
               </a:defRPr>
             </a:pPr>
             <a:r>
-              <a:rPr dirty="0" err="1"/>
-              <a:t>Comienza</a:t>
-            </a:r>
-            <a:r>
-              <a:rPr dirty="0"/>
-              <a:t> hoy — 100% gratis, 100% </a:t>
-            </a:r>
-            <a:r>
-              <a:rPr dirty="0" err="1"/>
-              <a:t>tuyo</a:t>
-            </a:r>
-            <a:endParaRPr dirty="0"/>
+              <a:rPr lang="es-ES" noProof="0" dirty="0"/>
+              <a:t>Comienza hoy — 100% gratis, 100% tuyo</a:t>
+            </a:r>
           </a:p>
         </p:txBody>
       </p:sp>
@@ -7862,30 +8319,22 @@
               </a:defRPr>
             </a:pPr>
             <a:r>
-              <a:rPr lang="es-ES" dirty="0"/>
-              <a:t>p</a:t>
-            </a:r>
-            <a:r>
-              <a:rPr dirty="0" err="1"/>
-              <a:t>lanixor</a:t>
-            </a:r>
-            <a:r>
-              <a:rPr lang="es-ES" dirty="0"/>
-              <a:t>.</a:t>
-            </a:r>
-            <a:r>
-              <a:rPr lang="es-ES" dirty="0" err="1"/>
-              <a:t>codenized</a:t>
-            </a:r>
-            <a:r>
-              <a:rPr dirty="0"/>
-              <a:t>.com  |  by </a:t>
-            </a:r>
-            <a:r>
-              <a:rPr dirty="0" err="1"/>
+              <a:rPr lang="es-ES" noProof="0" dirty="0"/>
+              <a:t>planixor.codenized.com  |  </a:t>
+            </a:r>
+            <a:r>
+              <a:rPr lang="es-ES" noProof="0" dirty="0" err="1"/>
+              <a:t>by</a:t>
+            </a:r>
+            <a:r>
+              <a:rPr lang="es-ES" noProof="0" dirty="0"/>
+              <a:t> </a:t>
+            </a:r>
+            <a:r>
+              <a:rPr lang="es-ES" noProof="0" dirty="0" err="1"/>
               <a:t>Codenized</a:t>
             </a:r>
-            <a:endParaRPr dirty="0"/>
+            <a:endParaRPr lang="es-ES" noProof="0" dirty="0"/>
           </a:p>
         </p:txBody>
       </p:sp>
@@ -7920,8 +8369,22 @@
               </a:defRPr>
             </a:pPr>
             <a:r>
-              <a:t>Web (PWA) + Android  |  Offline-First  |  Self-Hosted Sync</a:t>
-            </a:r>
+              <a:rPr lang="es-ES" noProof="0" dirty="0"/>
+              <a:t>Web (PWA) + Android  |  Offline-First  |  Self-</a:t>
+            </a:r>
+            <a:r>
+              <a:rPr lang="es-ES" noProof="0" dirty="0" err="1"/>
+              <a:t>Hosted</a:t>
+            </a:r>
+            <a:r>
+              <a:rPr lang="es-ES" noProof="0" dirty="0"/>
+              <a:t> </a:t>
+            </a:r>
+            <a:r>
+              <a:rPr lang="es-ES" noProof="0" dirty="0" err="1"/>
+              <a:t>Sync</a:t>
+            </a:r>
+            <a:endParaRPr lang="es-ES" noProof="0" dirty="0"/>
           </a:p>
         </p:txBody>
       </p:sp>
@@ -8034,7 +8497,7 @@
           <a:lstStyle/>
           <a:p>
             <a:pPr algn="ctr"/>
-            <a:endParaRPr/>
+            <a:endParaRPr lang="es-ES" noProof="0" dirty="0"/>
           </a:p>
         </p:txBody>
       </p:sp>
@@ -8047,7 +8510,7 @@
         <p:spPr>
           <a:xfrm>
             <a:off x="731520" y="457200"/>
-            <a:ext cx="9144000" cy="731520"/>
+            <a:ext cx="9144000" cy="646331"/>
           </a:xfrm>
           <a:prstGeom prst="rect">
             <a:avLst/>
@@ -8069,7 +8532,8 @@
               </a:defRPr>
             </a:pPr>
             <a:r>
-              <a:t>La Solucion: Planixor</a:t>
+              <a:rPr lang="es-ES" noProof="0" dirty="0"/>
+              <a:t>La Solución: Planixor</a:t>
             </a:r>
           </a:p>
         </p:txBody>
@@ -8083,7 +8547,7 @@
         <p:spPr>
           <a:xfrm>
             <a:off x="731520" y="1371600"/>
-            <a:ext cx="10058400" cy="1097280"/>
+            <a:ext cx="10058400" cy="707886"/>
           </a:xfrm>
           <a:prstGeom prst="rect">
             <a:avLst/>
@@ -8105,7 +8569,16 @@
               </a:defRPr>
             </a:pPr>
             <a:r>
-              <a:t>Una aplicacion unificada de gestion de turnos y horarios que funciona 100% offline, con sincronizacion opcional auto-hospedada. Tus datos, tu control.</a:t>
+              <a:rPr lang="es-ES" noProof="0" dirty="0"/>
+              <a:t>Una aplicación unificada de gestión de turnos y horarios que funciona 100% offline, con sincronización opcional </a:t>
+            </a:r>
+            <a:r>
+              <a:rPr lang="es-ES" noProof="0" dirty="0" err="1"/>
+              <a:t>auto-hospedada</a:t>
+            </a:r>
+            <a:r>
+              <a:rPr lang="es-ES" noProof="0" dirty="0"/>
+              <a:t>. Tus datos, tu control.</a:t>
             </a:r>
           </a:p>
         </p:txBody>
@@ -8119,7 +8592,7 @@
         <p:spPr>
           <a:xfrm>
             <a:off x="731520" y="2743200"/>
-            <a:ext cx="10058400" cy="3657600"/>
+            <a:ext cx="10058400" cy="2267287"/>
           </a:xfrm>
           <a:prstGeom prst="rect">
             <a:avLst/>
@@ -8144,6 +8617,7 @@
               </a:defRPr>
             </a:pPr>
             <a:r>
+              <a:rPr lang="es-ES" noProof="0" dirty="0"/>
               <a:t>Offline-First: funciona completamente sin internet</a:t>
             </a:r>
           </a:p>
@@ -8160,6 +8634,7 @@
               </a:defRPr>
             </a:pPr>
             <a:r>
+              <a:rPr lang="es-ES" noProof="0" dirty="0"/>
               <a:t>Privacidad total: datos almacenados solo en tu dispositivo</a:t>
             </a:r>
           </a:p>
@@ -8176,7 +8651,8 @@
               </a:defRPr>
             </a:pPr>
             <a:r>
-              <a:t>Sincronizacion opcional: tu propio servidor, tus reglas</a:t>
+              <a:rPr lang="es-ES" noProof="0" dirty="0"/>
+              <a:t>Sincronización opcional: tu propio servidor, tus reglas</a:t>
             </a:r>
           </a:p>
           <a:p>
@@ -8192,6 +8668,7 @@
               </a:defRPr>
             </a:pPr>
             <a:r>
+              <a:rPr lang="es-ES" noProof="0" dirty="0"/>
               <a:t>Multiplataforma: Web PWA + Android nativo</a:t>
             </a:r>
           </a:p>
@@ -8208,6 +8685,7 @@
               </a:defRPr>
             </a:pPr>
             <a:r>
+              <a:rPr lang="es-ES" noProof="0" dirty="0"/>
               <a:t>Interfaz moderna y limpia con modo claro/oscuro</a:t>
             </a:r>
           </a:p>
@@ -8224,7 +8702,8 @@
               </a:defRPr>
             </a:pPr>
             <a:r>
-              <a:t>Bilingue desde el primer dia: Espanol e Ingles</a:t>
+              <a:rPr lang="es-ES" noProof="0" dirty="0"/>
+              <a:t>Bilingüe desde el primer día: Español e Ingles</a:t>
             </a:r>
           </a:p>
         </p:txBody>
@@ -8332,7 +8811,7 @@
           <a:lstStyle/>
           <a:p>
             <a:pPr algn="ctr"/>
-            <a:endParaRPr/>
+            <a:endParaRPr lang="es-ES" noProof="0" dirty="0"/>
           </a:p>
         </p:txBody>
       </p:sp>
@@ -8367,18 +8846,9 @@
               </a:defRPr>
             </a:pPr>
             <a:r>
-              <a:rPr dirty="0" err="1"/>
-              <a:t>Funcionalidades</a:t>
-            </a:r>
-            <a:r>
-              <a:rPr dirty="0"/>
-              <a:t> </a:t>
-            </a:r>
-            <a:r>
-              <a:rPr dirty="0" err="1"/>
-              <a:t>Principales</a:t>
-            </a:r>
-            <a:endParaRPr dirty="0"/>
+              <a:rPr lang="es-ES" noProof="0" dirty="0"/>
+              <a:t>Funcionalidades Principales</a:t>
+            </a:r>
           </a:p>
         </p:txBody>
       </p:sp>
@@ -8425,10 +8895,9 @@
               <a:defRPr sz="1600"/>
             </a:pPr>
             <a:r>
-              <a:rPr lang="es-ES" dirty="0"/>
+              <a:rPr lang="es-ES" noProof="0" dirty="0"/>
               <a:t>🗓️</a:t>
             </a:r>
-            <a:endParaRPr dirty="0"/>
           </a:p>
         </p:txBody>
       </p:sp>
@@ -8463,6 +8932,7 @@
               </a:defRPr>
             </a:pPr>
             <a:r>
+              <a:rPr lang="es-ES" noProof="0" dirty="0"/>
               <a:t>Calendario</a:t>
             </a:r>
           </a:p>
@@ -8477,7 +8947,7 @@
         <p:spPr>
           <a:xfrm>
             <a:off x="1463040" y="1783080"/>
-            <a:ext cx="3200400" cy="548640"/>
+            <a:ext cx="3200400" cy="461665"/>
           </a:xfrm>
           <a:prstGeom prst="rect">
             <a:avLst/>
@@ -8499,7 +8969,8 @@
               </a:defRPr>
             </a:pPr>
             <a:r>
-              <a:t>Vistas Dia/Semana/Mes/Anio con navegacion intuitiva</a:t>
+              <a:rPr lang="es-ES" noProof="0" dirty="0"/>
+              <a:t>Vistas Dia/Semana/Mes/Año con navegación intuitiva</a:t>
             </a:r>
           </a:p>
         </p:txBody>
@@ -8547,10 +9018,9 @@
               <a:defRPr sz="1600"/>
             </a:pPr>
             <a:r>
-              <a:rPr lang="es-ES" dirty="0"/>
+              <a:rPr lang="es-ES" noProof="0" dirty="0"/>
               <a:t>🕓</a:t>
             </a:r>
-            <a:endParaRPr dirty="0"/>
           </a:p>
         </p:txBody>
       </p:sp>
@@ -8585,6 +9055,7 @@
               </a:defRPr>
             </a:pPr>
             <a:r>
+              <a:rPr lang="es-ES" noProof="0" dirty="0"/>
               <a:t>Turnos</a:t>
             </a:r>
           </a:p>
@@ -8621,6 +9092,7 @@
               </a:defRPr>
             </a:pPr>
             <a:r>
+              <a:rPr lang="es-ES" noProof="0" dirty="0"/>
               <a:t>Plantillas reutilizables con colores, emojis e iconos</a:t>
             </a:r>
           </a:p>
@@ -8669,10 +9141,9 @@
               <a:defRPr sz="1600"/>
             </a:pPr>
             <a:r>
-              <a:rPr lang="es-ES" dirty="0"/>
+              <a:rPr lang="es-ES" noProof="0" dirty="0"/>
               <a:t>⏰</a:t>
             </a:r>
-            <a:endParaRPr dirty="0"/>
           </a:p>
         </p:txBody>
       </p:sp>
@@ -8707,6 +9178,7 @@
               </a:defRPr>
             </a:pPr>
             <a:r>
+              <a:rPr lang="es-ES" noProof="0" dirty="0"/>
               <a:t>Recordatorios</a:t>
             </a:r>
           </a:p>
@@ -8721,7 +9193,7 @@
         <p:spPr>
           <a:xfrm>
             <a:off x="1463040" y="5074920"/>
-            <a:ext cx="3200400" cy="548640"/>
+            <a:ext cx="3200400" cy="276999"/>
           </a:xfrm>
           <a:prstGeom prst="rect">
             <a:avLst/>
@@ -8743,7 +9215,8 @@
               </a:defRPr>
             </a:pPr>
             <a:r>
-              <a:t>Templates para eventos recurrentes y tareas</a:t>
+              <a:rPr lang="es-ES" noProof="0" dirty="0"/>
+              <a:t>Plantillas para eventos recurrentes y tareas</a:t>
             </a:r>
           </a:p>
         </p:txBody>
@@ -8791,10 +9264,9 @@
               <a:defRPr sz="1600"/>
             </a:pPr>
             <a:r>
-              <a:rPr lang="es-ES" dirty="0"/>
+              <a:rPr lang="es-ES" noProof="0" dirty="0"/>
               <a:t>📣</a:t>
             </a:r>
-            <a:endParaRPr dirty="0"/>
           </a:p>
         </p:txBody>
       </p:sp>
@@ -8829,6 +9301,7 @@
               </a:defRPr>
             </a:pPr>
             <a:r>
+              <a:rPr lang="es-ES" noProof="0" dirty="0"/>
               <a:t>Eventos</a:t>
             </a:r>
           </a:p>
@@ -8865,6 +9338,7 @@
               </a:defRPr>
             </a:pPr>
             <a:r>
+              <a:rPr lang="es-ES" noProof="0" dirty="0"/>
               <a:t>Eventos vinculados a turnos o recordatorios</a:t>
             </a:r>
           </a:p>
@@ -8913,10 +9387,9 @@
               <a:defRPr sz="1600"/>
             </a:pPr>
             <a:r>
-              <a:rPr lang="es-ES" dirty="0"/>
+              <a:rPr lang="es-ES" noProof="0" dirty="0"/>
               <a:t>📊</a:t>
             </a:r>
-            <a:endParaRPr dirty="0"/>
           </a:p>
         </p:txBody>
       </p:sp>
@@ -8951,6 +9424,7 @@
               </a:defRPr>
             </a:pPr>
             <a:r>
+              <a:rPr lang="es-ES" noProof="0" dirty="0"/>
               <a:t>Informes</a:t>
             </a:r>
           </a:p>
@@ -8965,7 +9439,7 @@
         <p:spPr>
           <a:xfrm>
             <a:off x="6949440" y="3429000"/>
-            <a:ext cx="3200400" cy="548640"/>
+            <a:ext cx="3200400" cy="276999"/>
           </a:xfrm>
           <a:prstGeom prst="rect">
             <a:avLst/>
@@ -8987,7 +9461,8 @@
               </a:defRPr>
             </a:pPr>
             <a:r>
-              <a:t>Estadisticas visuales de horas trabajadas</a:t>
+              <a:rPr lang="es-ES" noProof="0" dirty="0"/>
+              <a:t>Estadísticas visuales de horas trabajadas</a:t>
             </a:r>
           </a:p>
         </p:txBody>
@@ -9035,10 +9510,9 @@
               <a:defRPr sz="1600"/>
             </a:pPr>
             <a:r>
-              <a:rPr lang="es-ES" dirty="0"/>
+              <a:rPr lang="es-ES" noProof="0" dirty="0"/>
               <a:t>📨</a:t>
             </a:r>
-            <a:endParaRPr dirty="0"/>
           </a:p>
         </p:txBody>
       </p:sp>
@@ -9073,6 +9547,7 @@
               </a:defRPr>
             </a:pPr>
             <a:r>
+              <a:rPr lang="es-ES" noProof="0" dirty="0"/>
               <a:t>Notificaciones</a:t>
             </a:r>
           </a:p>
@@ -9109,6 +9584,7 @@
               </a:defRPr>
             </a:pPr>
             <a:r>
+              <a:rPr lang="es-ES" noProof="0" dirty="0"/>
               <a:t>Alertas configurables: inicio, 10min, 1h, 1dia</a:t>
             </a:r>
           </a:p>
@@ -9187,7 +9663,7 @@
           <a:lstStyle/>
           <a:p>
             <a:pPr algn="ctr"/>
-            <a:endParaRPr/>
+            <a:endParaRPr lang="es-ES" noProof="0" dirty="0"/>
           </a:p>
         </p:txBody>
       </p:sp>
@@ -9222,6 +9698,7 @@
               </a:defRPr>
             </a:pPr>
             <a:r>
+              <a:rPr lang="es-ES" noProof="0" dirty="0"/>
               <a:t>Calendario Inteligente</a:t>
             </a:r>
           </a:p>
@@ -9236,7 +9713,7 @@
         <p:spPr>
           <a:xfrm>
             <a:off x="731520" y="1280160"/>
-            <a:ext cx="10058400" cy="731520"/>
+            <a:ext cx="10058400" cy="369332"/>
           </a:xfrm>
           <a:prstGeom prst="rect">
             <a:avLst/>
@@ -9258,7 +9735,8 @@
               </a:defRPr>
             </a:pPr>
             <a:r>
-              <a:t>Tu horario completo en una sola vista, con 4 modos de visualizacion</a:t>
+              <a:rPr lang="es-ES" noProof="0" dirty="0"/>
+              <a:t>Tu horario completo en una sola vista, con 4 modos de visualización</a:t>
             </a:r>
           </a:p>
         </p:txBody>
@@ -9272,7 +9750,7 @@
         <p:spPr>
           <a:xfrm>
             <a:off x="731520" y="2103120"/>
-            <a:ext cx="10058400" cy="4114800"/>
+            <a:ext cx="10058400" cy="3447098"/>
           </a:xfrm>
           <a:prstGeom prst="rect">
             <a:avLst/>
@@ -9297,32 +9775,8 @@
               </a:defRPr>
             </a:pPr>
             <a:r>
-              <a:rPr dirty="0"/>
-              <a:t>Vista Dia: Linea de </a:t>
-            </a:r>
-            <a:r>
-              <a:rPr dirty="0" err="1"/>
-              <a:t>tiempo</a:t>
-            </a:r>
-            <a:r>
-              <a:rPr dirty="0"/>
-              <a:t> vertical con </a:t>
-            </a:r>
-            <a:r>
-              <a:rPr dirty="0" err="1"/>
-              <a:t>indicador</a:t>
-            </a:r>
-            <a:r>
-              <a:rPr dirty="0"/>
-              <a:t> de hora actual (</a:t>
-            </a:r>
-            <a:r>
-              <a:rPr dirty="0" err="1"/>
-              <a:t>estilo</a:t>
-            </a:r>
-            <a:r>
-              <a:rPr dirty="0"/>
-              <a:t> Google Calendar)</a:t>
+              <a:rPr lang="es-ES" noProof="0" dirty="0"/>
+              <a:t>Vista Dia: Línea de tiempo vertical con indicador de hora actual (estilo Google Calendar)</a:t>
             </a:r>
           </a:p>
           <a:p>
@@ -9338,48 +9792,8 @@
               </a:defRPr>
             </a:pPr>
             <a:r>
-              <a:rPr dirty="0"/>
-              <a:t>Vista Semana: </a:t>
-            </a:r>
-            <a:r>
-              <a:rPr dirty="0" err="1"/>
-              <a:t>Cuadricula</a:t>
-            </a:r>
-            <a:r>
-              <a:rPr dirty="0"/>
-              <a:t> de 7 </a:t>
-            </a:r>
-            <a:r>
-              <a:rPr dirty="0" err="1"/>
-              <a:t>dias</a:t>
-            </a:r>
-            <a:r>
-              <a:rPr dirty="0"/>
-              <a:t> con </a:t>
-            </a:r>
-            <a:r>
-              <a:rPr dirty="0" err="1"/>
-              <a:t>bloques</a:t>
-            </a:r>
-            <a:r>
-              <a:rPr dirty="0"/>
-              <a:t> de </a:t>
-            </a:r>
-            <a:r>
-              <a:rPr dirty="0" err="1"/>
-              <a:t>eventos</a:t>
-            </a:r>
-            <a:r>
-              <a:rPr dirty="0"/>
-              <a:t> </a:t>
-            </a:r>
-            <a:r>
-              <a:rPr dirty="0" err="1"/>
-              <a:t>por</a:t>
-            </a:r>
-            <a:r>
-              <a:rPr dirty="0"/>
-              <a:t> hora</a:t>
+              <a:rPr lang="es-ES" noProof="0" dirty="0"/>
+              <a:t>Vista Semana: Cuadricula de 7 días con bloques de eventos por hora</a:t>
             </a:r>
           </a:p>
           <a:p>
@@ -9395,38 +9809,9 @@
               </a:defRPr>
             </a:pPr>
             <a:r>
-              <a:rPr dirty="0"/>
-              <a:t>Vista Mes: Vista </a:t>
-            </a:r>
-            <a:r>
-              <a:rPr dirty="0" err="1"/>
-              <a:t>mensual</a:t>
-            </a:r>
-            <a:r>
-              <a:rPr dirty="0"/>
-              <a:t> con </a:t>
-            </a:r>
-            <a:r>
-              <a:rPr dirty="0" err="1"/>
-              <a:t>indicadores</a:t>
-            </a:r>
-            <a:r>
-              <a:rPr dirty="0"/>
-              <a:t> de color </a:t>
-            </a:r>
-            <a:r>
-              <a:rPr dirty="0" err="1"/>
-              <a:t>por</a:t>
-            </a:r>
-            <a:r>
-              <a:rPr dirty="0"/>
-              <a:t> </a:t>
-            </a:r>
-            <a:r>
-              <a:rPr dirty="0" err="1"/>
-              <a:t>dia</a:t>
-            </a:r>
-            <a:endParaRPr dirty="0"/>
+              <a:rPr lang="es-ES" noProof="0" dirty="0"/>
+              <a:t>Vista Mes: Vista mensual con indicadores de color por día</a:t>
+            </a:r>
           </a:p>
           <a:p>
             <a:pPr>
@@ -9441,38 +9826,9 @@
               </a:defRPr>
             </a:pPr>
             <a:r>
-              <a:rPr dirty="0"/>
-              <a:t>Vista Anio: Panorama </a:t>
-            </a:r>
-            <a:r>
-              <a:rPr dirty="0" err="1"/>
-              <a:t>anual</a:t>
-            </a:r>
-            <a:r>
-              <a:rPr dirty="0"/>
-              <a:t> </a:t>
-            </a:r>
-            <a:r>
-              <a:rPr dirty="0" err="1"/>
-              <a:t>compacto</a:t>
-            </a:r>
-            <a:r>
-              <a:rPr dirty="0"/>
-              <a:t> para </a:t>
-            </a:r>
-            <a:r>
-              <a:rPr dirty="0" err="1"/>
-              <a:t>planificacion</a:t>
-            </a:r>
-            <a:r>
-              <a:rPr dirty="0"/>
-              <a:t> a largo </a:t>
-            </a:r>
-            <a:r>
-              <a:rPr dirty="0" err="1"/>
-              <a:t>plazo</a:t>
-            </a:r>
-            <a:endParaRPr dirty="0"/>
+              <a:rPr lang="es-ES" noProof="0" dirty="0"/>
+              <a:t>Vista Año: Panorama anual compacto para planificación a largo plazo</a:t>
+            </a:r>
           </a:p>
           <a:p>
             <a:pPr>
@@ -9487,36 +9843,8 @@
               </a:defRPr>
             </a:pPr>
             <a:r>
-              <a:rPr dirty="0" err="1"/>
-              <a:t>Navegacion</a:t>
-            </a:r>
-            <a:r>
-              <a:rPr dirty="0"/>
-              <a:t> </a:t>
-            </a:r>
-            <a:r>
-              <a:rPr dirty="0" err="1"/>
-              <a:t>rapida</a:t>
-            </a:r>
-            <a:r>
-              <a:rPr dirty="0"/>
-              <a:t> con </a:t>
-            </a:r>
-            <a:r>
-              <a:rPr dirty="0" err="1"/>
-              <a:t>flechas</a:t>
-            </a:r>
-            <a:r>
-              <a:rPr dirty="0"/>
-              <a:t> y </a:t>
-            </a:r>
-            <a:r>
-              <a:rPr dirty="0" err="1"/>
-              <a:t>boton</a:t>
-            </a:r>
-            <a:r>
-              <a:rPr dirty="0"/>
-              <a:t> 'Hoy'</a:t>
+              <a:rPr lang="es-ES" noProof="0" dirty="0"/>
+              <a:t>Navegación rápida con flechas y botón 'Hoy'</a:t>
             </a:r>
           </a:p>
           <a:p>
@@ -9532,42 +9860,9 @@
               </a:defRPr>
             </a:pPr>
             <a:r>
-              <a:rPr dirty="0" err="1"/>
-              <a:t>Eventos</a:t>
-            </a:r>
-            <a:r>
-              <a:rPr dirty="0"/>
-              <a:t> con </a:t>
-            </a:r>
-            <a:r>
-              <a:rPr dirty="0" err="1"/>
-              <a:t>bloques</a:t>
-            </a:r>
-            <a:r>
-              <a:rPr dirty="0"/>
-              <a:t> de color </a:t>
-            </a:r>
-            <a:r>
-              <a:rPr dirty="0" err="1"/>
-              <a:t>segun</a:t>
-            </a:r>
-            <a:r>
-              <a:rPr dirty="0"/>
-              <a:t> </a:t>
-            </a:r>
-            <a:r>
-              <a:rPr dirty="0" err="1"/>
-              <a:t>tipo</a:t>
-            </a:r>
-            <a:r>
-              <a:rPr dirty="0"/>
-              <a:t> de </a:t>
-            </a:r>
-            <a:r>
-              <a:rPr dirty="0" err="1"/>
-              <a:t>turno</a:t>
-            </a:r>
-            <a:endParaRPr dirty="0"/>
+              <a:rPr lang="es-ES" noProof="0" dirty="0"/>
+              <a:t>Eventos con bloques de color según tipo de turno</a:t>
+            </a:r>
           </a:p>
           <a:p>
             <a:pPr>
@@ -9582,26 +9877,14 @@
               </a:defRPr>
             </a:pPr>
             <a:r>
-              <a:rPr dirty="0" err="1"/>
-              <a:t>Soporte</a:t>
-            </a:r>
-            <a:r>
-              <a:rPr dirty="0"/>
-              <a:t> para </a:t>
-            </a:r>
-            <a:r>
-              <a:rPr dirty="0" err="1"/>
-              <a:t>eventos</a:t>
-            </a:r>
-            <a:r>
-              <a:rPr dirty="0"/>
-              <a:t> multi-</a:t>
-            </a:r>
-            <a:r>
-              <a:rPr dirty="0" err="1"/>
-              <a:t>dia</a:t>
-            </a:r>
-            <a:endParaRPr dirty="0"/>
+              <a:rPr lang="es-ES" noProof="0" dirty="0"/>
+              <a:t>Soporte para eventos </a:t>
+            </a:r>
+            <a:r>
+              <a:rPr lang="es-ES" noProof="0" dirty="0" err="1"/>
+              <a:t>multi-día</a:t>
+            </a:r>
+            <a:endParaRPr lang="es-ES" noProof="0" dirty="0"/>
           </a:p>
           <a:p>
             <a:pPr>
@@ -9616,62 +9899,53 @@
               </a:defRPr>
             </a:pPr>
             <a:r>
-              <a:rPr dirty="0"/>
-              <a:t>Un </a:t>
-            </a:r>
-            <a:r>
-              <a:rPr dirty="0" err="1"/>
-              <a:t>turno</a:t>
-            </a:r>
-            <a:r>
-              <a:rPr dirty="0"/>
-              <a:t> </a:t>
-            </a:r>
-            <a:r>
-              <a:rPr dirty="0" err="1"/>
-              <a:t>por</a:t>
-            </a:r>
-            <a:r>
-              <a:rPr dirty="0"/>
-              <a:t> </a:t>
-            </a:r>
-            <a:r>
-              <a:rPr dirty="0" err="1"/>
-              <a:t>dia</a:t>
-            </a:r>
-            <a:r>
-              <a:rPr dirty="0"/>
-              <a:t>: </a:t>
-            </a:r>
-            <a:r>
-              <a:rPr dirty="0" err="1"/>
-              <a:t>restriccion</a:t>
-            </a:r>
-            <a:r>
-              <a:rPr dirty="0"/>
-              <a:t> </a:t>
-            </a:r>
-            <a:r>
-              <a:rPr dirty="0" err="1"/>
-              <a:t>inteligente</a:t>
-            </a:r>
-            <a:r>
-              <a:rPr dirty="0"/>
-              <a:t> para </a:t>
-            </a:r>
-            <a:r>
-              <a:rPr dirty="0" err="1"/>
-              <a:t>evitar</a:t>
-            </a:r>
-            <a:r>
-              <a:rPr dirty="0"/>
-              <a:t> </a:t>
-            </a:r>
-            <a:r>
-              <a:rPr dirty="0" err="1"/>
-              <a:t>conflictos</a:t>
-            </a:r>
-            <a:endParaRPr dirty="0"/>
+              <a:rPr lang="es-ES" noProof="0" dirty="0"/>
+              <a:t>Un turno por día: restricción inteligente para evitar conflictos</a:t>
+            </a:r>
+          </a:p>
+          <a:p>
+            <a:pPr>
+              <a:spcAft>
+                <a:spcPts val="800"/>
+              </a:spcAft>
+              <a:defRPr sz="1600">
+                <a:solidFill>
+                  <a:srgbClr val="F9FAFB"/>
+                </a:solidFill>
+                <a:latin typeface="Calibri"/>
+              </a:defRPr>
+            </a:pPr>
+            <a:r>
+              <a:rPr lang="es-ES" sz="1500" noProof="0" dirty="0">
+                <a:solidFill>
+                  <a:srgbClr val="F9FAFB"/>
+                </a:solidFill>
+                <a:latin typeface="Calibri"/>
+              </a:rPr>
+              <a:t>Eventos de serie vinculados: editar/eliminar uno o toda la serie futura</a:t>
+            </a:r>
+          </a:p>
+          <a:p>
+            <a:pPr>
+              <a:spcAft>
+                <a:spcPts val="800"/>
+              </a:spcAft>
+              <a:defRPr sz="1600">
+                <a:solidFill>
+                  <a:srgbClr val="F9FAFB"/>
+                </a:solidFill>
+                <a:latin typeface="Calibri"/>
+              </a:defRPr>
+            </a:pPr>
+            <a:r>
+              <a:rPr lang="es-ES" sz="1500" noProof="0" dirty="0">
+                <a:solidFill>
+                  <a:srgbClr val="F9FAFB"/>
+                </a:solidFill>
+                <a:latin typeface="Calibri"/>
+              </a:rPr>
+              <a:t>Generación automática de eventos recurrentes desde recordatorios con repetición</a:t>
+            </a:r>
           </a:p>
         </p:txBody>
       </p:sp>
@@ -9778,7 +10052,7 @@
           <a:lstStyle/>
           <a:p>
             <a:pPr algn="ctr"/>
-            <a:endParaRPr/>
+            <a:endParaRPr lang="es-ES" noProof="0" dirty="0"/>
           </a:p>
         </p:txBody>
       </p:sp>
@@ -9813,10 +10087,9 @@
               </a:defRPr>
             </a:pPr>
             <a:r>
-              <a:rPr dirty="0" err="1"/>
+              <a:rPr lang="es-ES" noProof="0" dirty="0"/>
               <a:t>Turnos</a:t>
             </a:r>
-            <a:endParaRPr dirty="0"/>
           </a:p>
         </p:txBody>
       </p:sp>
@@ -9851,6 +10124,7 @@
               </a:defRPr>
             </a:pPr>
             <a:r>
+              <a:rPr lang="es-ES" noProof="0" dirty="0"/>
               <a:t>Turnos</a:t>
             </a:r>
           </a:p>
@@ -9865,7 +10139,7 @@
         <p:spPr>
           <a:xfrm>
             <a:off x="731520" y="1920240"/>
-            <a:ext cx="5029200" cy="4114800"/>
+            <a:ext cx="5029200" cy="1990288"/>
           </a:xfrm>
           <a:prstGeom prst="rect">
             <a:avLst/>
@@ -9890,6 +10164,7 @@
               </a:defRPr>
             </a:pPr>
             <a:r>
+              <a:rPr lang="es-ES" noProof="0" dirty="0"/>
               <a:t>Plantillas reutilizables con nombre, emoji y color</a:t>
             </a:r>
           </a:p>
@@ -9906,7 +10181,8 @@
               </a:defRPr>
             </a:pPr>
             <a:r>
-              <a:t>Calculo automatico de horas trabajadas</a:t>
+              <a:rPr lang="es-ES" noProof="0" dirty="0"/>
+              <a:t>Calculo automático de horas trabajadas</a:t>
             </a:r>
           </a:p>
           <a:p>
@@ -9922,6 +10198,7 @@
               </a:defRPr>
             </a:pPr>
             <a:r>
+              <a:rPr lang="es-ES" noProof="0" dirty="0"/>
               <a:t>Soporte para turnos de 24h y cruce de medianoche</a:t>
             </a:r>
           </a:p>
@@ -9938,6 +10215,7 @@
               </a:defRPr>
             </a:pPr>
             <a:r>
+              <a:rPr lang="es-ES" noProof="0" dirty="0"/>
               <a:t>Activar/desactivar sin eliminar</a:t>
             </a:r>
           </a:p>
@@ -9954,6 +10232,7 @@
               </a:defRPr>
             </a:pPr>
             <a:r>
+              <a:rPr lang="es-ES" noProof="0" dirty="0"/>
               <a:t>Paleta de 45 colores (9 familias x 5 tonos)</a:t>
             </a:r>
           </a:p>
@@ -9970,6 +10249,7 @@
               </a:defRPr>
             </a:pPr>
             <a:r>
+              <a:rPr lang="es-ES" noProof="0" dirty="0"/>
               <a:t>Selector de emojis integrado</a:t>
             </a:r>
           </a:p>
@@ -10090,7 +10370,7 @@
           <a:lstStyle/>
           <a:p>
             <a:pPr algn="ctr"/>
-            <a:endParaRPr/>
+            <a:endParaRPr lang="es-ES" noProof="0" dirty="0"/>
           </a:p>
         </p:txBody>
       </p:sp>
@@ -10131,10 +10411,9 @@
               </a:defRPr>
             </a:pPr>
             <a:r>
-              <a:rPr dirty="0" err="1"/>
+              <a:rPr lang="es-ES" noProof="0" dirty="0"/>
               <a:t>Recordatorios</a:t>
             </a:r>
-            <a:endParaRPr dirty="0"/>
           </a:p>
         </p:txBody>
       </p:sp>
@@ -10175,6 +10454,7 @@
               </a:defRPr>
             </a:pPr>
             <a:r>
+              <a:rPr lang="es-ES" noProof="0" dirty="0"/>
               <a:t>Recordatorios</a:t>
             </a:r>
           </a:p>
@@ -10195,7 +10475,7 @@
         <p:spPr>
           <a:xfrm>
             <a:off x="6400800" y="1920240"/>
-            <a:ext cx="5029200" cy="4114800"/>
+            <a:ext cx="5029200" cy="2887970"/>
           </a:xfrm>
           <a:prstGeom prst="rect">
             <a:avLst/>
@@ -10220,7 +10500,8 @@
               </a:defRPr>
             </a:pPr>
             <a:r>
-              <a:t>Templates para eventos recurrentes</a:t>
+              <a:rPr lang="es-ES" noProof="0" dirty="0"/>
+              <a:t>Plantillas para eventos recurrentes</a:t>
             </a:r>
           </a:p>
           <a:p>
@@ -10236,6 +10517,7 @@
               </a:defRPr>
             </a:pPr>
             <a:r>
+              <a:rPr lang="es-ES" noProof="0" dirty="0"/>
               <a:t>Personalizables con emoji y color</a:t>
             </a:r>
           </a:p>
@@ -10252,7 +10534,8 @@
               </a:defRPr>
             </a:pPr>
             <a:r>
-              <a:t>Ideal para: reuniones, medicacion, tareas</a:t>
+              <a:rPr lang="es-ES" noProof="0" dirty="0"/>
+              <a:t>Ideal para: reuniones, medicación, tareas</a:t>
             </a:r>
           </a:p>
           <a:p>
@@ -10268,7 +10551,8 @@
               </a:defRPr>
             </a:pPr>
             <a:r>
-              <a:t>Activar/desactivar segun necesidad</a:t>
+              <a:rPr lang="es-ES" noProof="0" dirty="0"/>
+              <a:t>Activar/desactivar según necesidad</a:t>
             </a:r>
           </a:p>
           <a:p>
@@ -10284,8 +10568,14 @@
               </a:defRPr>
             </a:pPr>
             <a:r>
-              <a:t>Sincronizacion multi-dispositivo</a:t>
-            </a:r>
+              <a:rPr lang="es-ES" noProof="0" dirty="0"/>
+              <a:t>Sincronización </a:t>
+            </a:r>
+            <a:r>
+              <a:rPr lang="es-ES" noProof="0" dirty="0" err="1"/>
+              <a:t>multi-dispositivo</a:t>
+            </a:r>
+            <a:endParaRPr lang="es-ES" noProof="0" dirty="0"/>
           </a:p>
           <a:p>
             <a:pPr>
@@ -10300,8 +10590,56 @@
               </a:defRPr>
             </a:pPr>
             <a:r>
-              <a:t>Vinculacion directa con eventos del calendario</a:t>
-            </a:r>
+              <a:rPr lang="es-ES" noProof="0" dirty="0"/>
+              <a:t>Vinculación directa con eventos del calendario</a:t>
+            </a:r>
+          </a:p>
+          <a:p>
+            <a:pPr>
+              <a:spcAft>
+                <a:spcPts val="800"/>
+              </a:spcAft>
+              <a:defRPr sz="1500">
+                <a:solidFill>
+                  <a:srgbClr val="F9FAFB"/>
+                </a:solidFill>
+                <a:latin typeface="Calibri"/>
+              </a:defRPr>
+            </a:pPr>
+            <a:r>
+              <a:rPr lang="es-ES" sz="1500" noProof="0" dirty="0">
+                <a:solidFill>
+                  <a:srgbClr val="F9FAFB"/>
+                </a:solidFill>
+                <a:latin typeface="Calibri"/>
+              </a:rPr>
+              <a:t>Series de repetición: semanal, mensual o anual</a:t>
+            </a:r>
+          </a:p>
+          <a:p>
+            <a:r>
+              <a:rPr lang="es-ES" sz="1500" noProof="0" dirty="0">
+                <a:solidFill>
+                  <a:srgbClr val="F9FAFB"/>
+                </a:solidFill>
+                <a:latin typeface="Calibri"/>
+              </a:rPr>
+              <a:t>Etiqueta de frecuencia visible en la tarjeta del recordatorio</a:t>
+            </a:r>
+          </a:p>
+          <a:p>
+            <a:pPr>
+              <a:spcAft>
+                <a:spcPts val="800"/>
+              </a:spcAft>
+              <a:defRPr sz="1500">
+                <a:solidFill>
+                  <a:srgbClr val="F9FAFB"/>
+                </a:solidFill>
+                <a:latin typeface="Calibri"/>
+              </a:defRPr>
+            </a:pPr>
+            <a:endParaRPr lang="es-ES" noProof="0" dirty="0"/>
           </a:p>
         </p:txBody>
       </p:sp>
@@ -10413,7 +10751,7 @@
           <a:lstStyle/>
           <a:p>
             <a:pPr algn="ctr"/>
-            <a:endParaRPr/>
+            <a:endParaRPr lang="es-ES" noProof="0" dirty="0"/>
           </a:p>
         </p:txBody>
       </p:sp>
@@ -10426,7 +10764,7 @@
         <p:spPr>
           <a:xfrm>
             <a:off x="731520" y="457200"/>
-            <a:ext cx="9144000" cy="731520"/>
+            <a:ext cx="9144000" cy="646331"/>
           </a:xfrm>
           <a:prstGeom prst="rect">
             <a:avLst/>
@@ -10448,7 +10786,8 @@
               </a:defRPr>
             </a:pPr>
             <a:r>
-              <a:t>Informes y Estadisticas</a:t>
+              <a:rPr lang="es-ES" noProof="0" dirty="0"/>
+              <a:t>Informes y Estadísticas</a:t>
             </a:r>
           </a:p>
         </p:txBody>
@@ -10462,7 +10801,7 @@
         <p:spPr>
           <a:xfrm>
             <a:off x="731520" y="1280160"/>
-            <a:ext cx="10058400" cy="731520"/>
+            <a:ext cx="10058400" cy="369332"/>
           </a:xfrm>
           <a:prstGeom prst="rect">
             <a:avLst/>
@@ -10484,7 +10823,8 @@
               </a:defRPr>
             </a:pPr>
             <a:r>
-              <a:t>Visualiza tu productividad con graficos claros y accionables</a:t>
+              <a:rPr lang="es-ES" noProof="0" dirty="0"/>
+              <a:t>Visualiza tu productividad con gráficos claros y accionables</a:t>
             </a:r>
           </a:p>
         </p:txBody>
@@ -10498,7 +10838,7 @@
         <p:spPr>
           <a:xfrm>
             <a:off x="731520" y="2103120"/>
-            <a:ext cx="5486400" cy="4114800"/>
+            <a:ext cx="5486400" cy="2431435"/>
           </a:xfrm>
           <a:prstGeom prst="rect">
             <a:avLst/>
@@ -10523,7 +10863,8 @@
               </a:defRPr>
             </a:pPr>
             <a:r>
-              <a:t>Horas trabajadas por dia, semana, mes o anio</a:t>
+              <a:rPr lang="es-ES" noProof="0" dirty="0"/>
+              <a:t>Horas trabajadas mes o año</a:t>
             </a:r>
           </a:p>
           <a:p>
@@ -10539,7 +10880,8 @@
               </a:defRPr>
             </a:pPr>
             <a:r>
-              <a:t>Graficos de barras para distribucion de horas</a:t>
+              <a:rPr lang="es-ES" noProof="0" dirty="0"/>
+              <a:t>Gráficos de barras para distribución de horas</a:t>
             </a:r>
           </a:p>
           <a:p>
@@ -10555,7 +10897,8 @@
               </a:defRPr>
             </a:pPr>
             <a:r>
-              <a:t>Graficos de dona para desglose por tipo de turno</a:t>
+              <a:rPr lang="es-ES" noProof="0" dirty="0"/>
+              <a:t>Gráficos de dona para desglose por tipo de turno</a:t>
             </a:r>
           </a:p>
           <a:p>
@@ -10571,7 +10914,8 @@
               </a:defRPr>
             </a:pPr>
             <a:r>
-              <a:t>Configuracion de objetivo anual de horas</a:t>
+              <a:rPr lang="es-ES" noProof="0" dirty="0"/>
+              <a:t>Configuración de objetivo anual de horas</a:t>
             </a:r>
           </a:p>
           <a:p>
@@ -10587,7 +10931,8 @@
               </a:defRPr>
             </a:pPr>
             <a:r>
-              <a:t>Actualizacion automatica al crear/modificar eventos</a:t>
+              <a:rPr lang="es-ES" noProof="0" dirty="0"/>
+              <a:t>Actualización automática al crear/modificar eventos</a:t>
             </a:r>
           </a:p>
           <a:p>
@@ -10603,6 +10948,7 @@
               </a:defRPr>
             </a:pPr>
             <a:r>
+              <a:rPr lang="es-ES" noProof="0" dirty="0"/>
               <a:t>Filtros por periodo temporal</a:t>
             </a:r>
           </a:p>
@@ -10619,6 +10965,7 @@
               </a:defRPr>
             </a:pPr>
             <a:r>
+              <a:rPr lang="es-ES" noProof="0" dirty="0"/>
               <a:t>Colores consistentes con la paleta de marca</a:t>
             </a:r>
           </a:p>
@@ -10739,7 +11086,7 @@
           <a:lstStyle/>
           <a:p>
             <a:pPr algn="ctr"/>
-            <a:endParaRPr/>
+            <a:endParaRPr lang="es-ES" noProof="0" dirty="0"/>
           </a:p>
         </p:txBody>
       </p:sp>
@@ -10780,10 +11127,10 @@
               </a:defRPr>
             </a:pPr>
             <a:r>
-              <a:rPr lang="es-ES" sz="3600" b="1" dirty="0"/>
+              <a:rPr lang="es-ES" sz="3600" b="1" noProof="0" dirty="0"/>
               <a:t>Modo Turno — Simplifica tu calendario</a:t>
             </a:r>
-            <a:endParaRPr dirty="0"/>
+            <a:endParaRPr lang="es-ES" noProof="0" dirty="0"/>
           </a:p>
         </p:txBody>
       </p:sp>
@@ -10824,10 +11171,10 @@
               </a:defRPr>
             </a:pPr>
             <a:r>
-              <a:rPr lang="es-ES" i="1" dirty="0"/>
+              <a:rPr lang="es-ES" i="1" noProof="0" dirty="0"/>
               <a:t>Un modo especializado para quienes gestionan turnos de trabajo</a:t>
             </a:r>
-            <a:endParaRPr dirty="0"/>
+            <a:endParaRPr lang="es-ES" noProof="0" dirty="0"/>
           </a:p>
         </p:txBody>
       </p:sp>
@@ -10860,7 +11207,7 @@
           <a:lstStyle/>
           <a:p>
             <a:r>
-              <a:rPr lang="es-ES" sz="1600" dirty="0">
+              <a:rPr lang="es-ES" sz="1600" noProof="0" dirty="0">
                 <a:solidFill>
                   <a:srgbClr val="F9FAFB"/>
                 </a:solidFill>
@@ -10870,7 +11217,7 @@
             </a:r>
           </a:p>
           <a:p>
-            <a:endParaRPr lang="es-ES" sz="1600" dirty="0">
+            <a:endParaRPr lang="es-ES" sz="1600" noProof="0" dirty="0">
               <a:solidFill>
                 <a:srgbClr val="F9FAFB"/>
               </a:solidFill>
@@ -10879,7 +11226,7 @@
           </a:p>
           <a:p>
             <a:r>
-              <a:rPr lang="es-ES" sz="1600" dirty="0">
+              <a:rPr lang="es-ES" sz="1600" noProof="0" dirty="0">
                 <a:solidFill>
                   <a:srgbClr val="F9FAFB"/>
                 </a:solidFill>
@@ -10889,7 +11236,7 @@
             </a:r>
           </a:p>
           <a:p>
-            <a:endParaRPr lang="es-ES" sz="1600" dirty="0">
+            <a:endParaRPr lang="es-ES" sz="1600" noProof="0" dirty="0">
               <a:solidFill>
                 <a:srgbClr val="F9FAFB"/>
               </a:solidFill>
@@ -10898,7 +11245,7 @@
           </a:p>
           <a:p>
             <a:r>
-              <a:rPr lang="es-ES" sz="1600" dirty="0">
+              <a:rPr lang="es-ES" sz="1600" noProof="0" dirty="0">
                 <a:solidFill>
                   <a:srgbClr val="F9FAFB"/>
                 </a:solidFill>
@@ -10908,7 +11255,7 @@
             </a:r>
           </a:p>
           <a:p>
-            <a:endParaRPr lang="es-ES" sz="1600" dirty="0">
+            <a:endParaRPr lang="es-ES" sz="1600" noProof="0" dirty="0">
               <a:solidFill>
                 <a:srgbClr val="F9FAFB"/>
               </a:solidFill>
@@ -10917,7 +11264,7 @@
           </a:p>
           <a:p>
             <a:r>
-              <a:rPr lang="es-ES" sz="1600" dirty="0">
+              <a:rPr lang="es-ES" sz="1600" noProof="0" dirty="0">
                 <a:solidFill>
                   <a:srgbClr val="F9FAFB"/>
                 </a:solidFill>
@@ -10927,7 +11274,7 @@
             </a:r>
           </a:p>
           <a:p>
-            <a:endParaRPr lang="es-ES" sz="1600" dirty="0">
+            <a:endParaRPr lang="es-ES" sz="1600" noProof="0" dirty="0">
               <a:solidFill>
                 <a:srgbClr val="F9FAFB"/>
               </a:solidFill>
@@ -10936,7 +11283,7 @@
           </a:p>
           <a:p>
             <a:r>
-              <a:rPr lang="es-ES" sz="1600" dirty="0">
+              <a:rPr lang="es-ES" sz="1600" noProof="0" dirty="0">
                 <a:solidFill>
                   <a:srgbClr val="F9FAFB"/>
                 </a:solidFill>
@@ -10946,7 +11293,7 @@
             </a:r>
           </a:p>
           <a:p>
-            <a:endParaRPr lang="es-ES" sz="1600" dirty="0">
+            <a:endParaRPr lang="es-ES" sz="1600" noProof="0" dirty="0">
               <a:solidFill>
                 <a:srgbClr val="F9FAFB"/>
               </a:solidFill>
@@ -10955,7 +11302,7 @@
           </a:p>
           <a:p>
             <a:r>
-              <a:rPr lang="es-ES" sz="1600" dirty="0">
+              <a:rPr lang="es-ES" sz="1600" noProof="0" dirty="0">
                 <a:solidFill>
                   <a:srgbClr val="F9FAFB"/>
                 </a:solidFill>
@@ -10964,7 +11311,7 @@
               <a:t>🌗 Actívalo cuando quieras — Un simple </a:t>
             </a:r>
             <a:r>
-              <a:rPr lang="es-ES" sz="1600" dirty="0" err="1">
+              <a:rPr lang="es-ES" sz="1600" noProof="0" dirty="0" err="1">
                 <a:solidFill>
                   <a:srgbClr val="F9FAFB"/>
                 </a:solidFill>
@@ -10973,7 +11320,7 @@
               <a:t>toggle</a:t>
             </a:r>
             <a:r>
-              <a:rPr lang="es-ES" sz="1600" dirty="0">
+              <a:rPr lang="es-ES" sz="1600" noProof="0" dirty="0">
                 <a:solidFill>
                   <a:srgbClr val="F9FAFB"/>
                 </a:solidFill>
@@ -10981,7 +11328,7 @@
               </a:rPr>
               <a:t> en Ajustes, efecto inmediato, sin reiniciar</a:t>
             </a:r>
-            <a:endParaRPr dirty="0"/>
+            <a:endParaRPr lang="es-ES" noProof="0" dirty="0"/>
           </a:p>
         </p:txBody>
       </p:sp>

</xml_diff>